<commit_message>
MAJ 15/01/25 projet 4
</commit_message>
<xml_diff>
--- a/Data_Analyst/Projet_2/rapport mensuel des actions marketing.pptx
+++ b/Data_Analyst/Projet_2/rapport mensuel des actions marketing.pptx
@@ -13,10 +13,10 @@
   <p:sldIdLst>
     <p:sldId id="256" r:id="rId5"/>
     <p:sldId id="300" r:id="rId6"/>
-    <p:sldId id="304" r:id="rId7"/>
-    <p:sldId id="305" r:id="rId8"/>
+    <p:sldId id="305" r:id="rId7"/>
+    <p:sldId id="308" r:id="rId8"/>
     <p:sldId id="306" r:id="rId9"/>
-    <p:sldId id="308" r:id="rId10"/>
+    <p:sldId id="304" r:id="rId10"/>
     <p:sldId id="276" r:id="rId11"/>
   </p:sldIdLst>
   <p:sldSz cx="12192000" cy="6858000"/>
@@ -154,27 +154,35 @@
 <pc:chgInfo xmlns:a="http://schemas.openxmlformats.org/drawingml/2006/main" xmlns:r="http://schemas.openxmlformats.org/officeDocument/2006/relationships" xmlns:ac="http://schemas.microsoft.com/office/drawing/2013/main/command" xmlns:pc="http://schemas.microsoft.com/office/powerpoint/2013/main/command">
   <pc:docChgLst>
     <pc:chgData name="Zied Belhocine" userId="200cc0e2b299676e" providerId="LiveId" clId="{9D5C2755-5B7D-406A-B8B3-AE8FBAA81AB3}"/>
-    <pc:docChg chg="custSel modSld">
-      <pc:chgData name="Zied Belhocine" userId="200cc0e2b299676e" providerId="LiveId" clId="{9D5C2755-5B7D-406A-B8B3-AE8FBAA81AB3}" dt="2026-01-08T11:23:37.438" v="220" actId="20577"/>
+    <pc:docChg chg="undo custSel addSld delSld modSld sldOrd">
+      <pc:chgData name="Zied Belhocine" userId="200cc0e2b299676e" providerId="LiveId" clId="{9D5C2755-5B7D-406A-B8B3-AE8FBAA81AB3}" dt="2026-01-09T16:22:46.845" v="1126" actId="20577"/>
       <pc:docMkLst>
         <pc:docMk/>
       </pc:docMkLst>
-      <pc:sldChg chg="modSp mod">
-        <pc:chgData name="Zied Belhocine" userId="200cc0e2b299676e" providerId="LiveId" clId="{9D5C2755-5B7D-406A-B8B3-AE8FBAA81AB3}" dt="2026-01-08T11:21:58.544" v="216" actId="20577"/>
+      <pc:sldChg chg="modSp mod ord modNotesTx">
+        <pc:chgData name="Zied Belhocine" userId="200cc0e2b299676e" providerId="LiveId" clId="{9D5C2755-5B7D-406A-B8B3-AE8FBAA81AB3}" dt="2026-01-09T16:22:46.845" v="1126" actId="20577"/>
         <pc:sldMkLst>
           <pc:docMk/>
           <pc:sldMk cId="4153042215" sldId="300"/>
         </pc:sldMkLst>
         <pc:spChg chg="mod">
-          <ac:chgData name="Zied Belhocine" userId="200cc0e2b299676e" providerId="LiveId" clId="{9D5C2755-5B7D-406A-B8B3-AE8FBAA81AB3}" dt="2026-01-08T11:21:58.544" v="216" actId="20577"/>
+          <ac:chgData name="Zied Belhocine" userId="200cc0e2b299676e" providerId="LiveId" clId="{9D5C2755-5B7D-406A-B8B3-AE8FBAA81AB3}" dt="2026-01-09T16:22:46.845" v="1126" actId="20577"/>
           <ac:spMkLst>
             <pc:docMk/>
             <pc:sldMk cId="4153042215" sldId="300"/>
             <ac:spMk id="10" creationId="{0519737F-9D2D-31DE-5686-D6F447D5D3F5}"/>
           </ac:spMkLst>
         </pc:spChg>
+        <pc:spChg chg="mod">
+          <ac:chgData name="Zied Belhocine" userId="200cc0e2b299676e" providerId="LiveId" clId="{9D5C2755-5B7D-406A-B8B3-AE8FBAA81AB3}" dt="2026-01-09T08:14:38.762" v="656" actId="1076"/>
+          <ac:spMkLst>
+            <pc:docMk/>
+            <pc:sldMk cId="4153042215" sldId="300"/>
+            <ac:spMk id="12" creationId="{F8A892BB-5431-CA08-0719-4F1CA5524A86}"/>
+          </ac:spMkLst>
+        </pc:spChg>
         <pc:picChg chg="mod">
-          <ac:chgData name="Zied Belhocine" userId="200cc0e2b299676e" providerId="LiveId" clId="{9D5C2755-5B7D-406A-B8B3-AE8FBAA81AB3}" dt="2026-01-08T11:21:33.900" v="205" actId="1076"/>
+          <ac:chgData name="Zied Belhocine" userId="200cc0e2b299676e" providerId="LiveId" clId="{9D5C2755-5B7D-406A-B8B3-AE8FBAA81AB3}" dt="2026-01-09T08:15:02.712" v="660" actId="1076"/>
           <ac:picMkLst>
             <pc:docMk/>
             <pc:sldMk cId="4153042215" sldId="300"/>
@@ -182,18 +190,157 @@
           </ac:picMkLst>
         </pc:picChg>
       </pc:sldChg>
-      <pc:sldChg chg="modSp mod">
-        <pc:chgData name="Zied Belhocine" userId="200cc0e2b299676e" providerId="LiveId" clId="{9D5C2755-5B7D-406A-B8B3-AE8FBAA81AB3}" dt="2026-01-08T11:23:37.438" v="220" actId="20577"/>
+      <pc:sldChg chg="modSp mod modNotesTx">
+        <pc:chgData name="Zied Belhocine" userId="200cc0e2b299676e" providerId="LiveId" clId="{9D5C2755-5B7D-406A-B8B3-AE8FBAA81AB3}" dt="2026-01-09T08:19:01.683" v="750" actId="1076"/>
+        <pc:sldMkLst>
+          <pc:docMk/>
+          <pc:sldMk cId="3063745067" sldId="304"/>
+        </pc:sldMkLst>
+        <pc:spChg chg="mod">
+          <ac:chgData name="Zied Belhocine" userId="200cc0e2b299676e" providerId="LiveId" clId="{9D5C2755-5B7D-406A-B8B3-AE8FBAA81AB3}" dt="2026-01-09T08:18:35.078" v="745" actId="14100"/>
+          <ac:spMkLst>
+            <pc:docMk/>
+            <pc:sldMk cId="3063745067" sldId="304"/>
+            <ac:spMk id="3" creationId="{E503D5C8-EABC-8DB3-766D-2D8D43C29F2E}"/>
+          </ac:spMkLst>
+        </pc:spChg>
+        <pc:spChg chg="mod">
+          <ac:chgData name="Zied Belhocine" userId="200cc0e2b299676e" providerId="LiveId" clId="{9D5C2755-5B7D-406A-B8B3-AE8FBAA81AB3}" dt="2026-01-09T08:14:31.795" v="655" actId="1076"/>
+          <ac:spMkLst>
+            <pc:docMk/>
+            <pc:sldMk cId="3063745067" sldId="304"/>
+            <ac:spMk id="5" creationId="{4F487A6A-202B-34F2-3157-3A0DB7CFF017}"/>
+          </ac:spMkLst>
+        </pc:spChg>
+        <pc:picChg chg="mod">
+          <ac:chgData name="Zied Belhocine" userId="200cc0e2b299676e" providerId="LiveId" clId="{9D5C2755-5B7D-406A-B8B3-AE8FBAA81AB3}" dt="2026-01-09T08:19:01.683" v="750" actId="1076"/>
+          <ac:picMkLst>
+            <pc:docMk/>
+            <pc:sldMk cId="3063745067" sldId="304"/>
+            <ac:picMk id="2" creationId="{2415FE7D-904B-B539-B403-F92F79825ED8}"/>
+          </ac:picMkLst>
+        </pc:picChg>
+      </pc:sldChg>
+      <pc:sldChg chg="modSp mod ord modNotesTx">
+        <pc:chgData name="Zied Belhocine" userId="200cc0e2b299676e" providerId="LiveId" clId="{9D5C2755-5B7D-406A-B8B3-AE8FBAA81AB3}" dt="2026-01-09T15:46:28.044" v="758"/>
+        <pc:sldMkLst>
+          <pc:docMk/>
+          <pc:sldMk cId="3998171594" sldId="305"/>
+        </pc:sldMkLst>
+        <pc:spChg chg="mod">
+          <ac:chgData name="Zied Belhocine" userId="200cc0e2b299676e" providerId="LiveId" clId="{9D5C2755-5B7D-406A-B8B3-AE8FBAA81AB3}" dt="2026-01-09T08:15:42.256" v="719" actId="1076"/>
+          <ac:spMkLst>
+            <pc:docMk/>
+            <pc:sldMk cId="3998171594" sldId="305"/>
+            <ac:spMk id="5" creationId="{5F2CDB22-66E5-2C01-0C7C-51F41FB5CFD6}"/>
+          </ac:spMkLst>
+        </pc:spChg>
+        <pc:spChg chg="mod">
+          <ac:chgData name="Zied Belhocine" userId="200cc0e2b299676e" providerId="LiveId" clId="{9D5C2755-5B7D-406A-B8B3-AE8FBAA81AB3}" dt="2026-01-09T08:15:15.872" v="664" actId="1076"/>
+          <ac:spMkLst>
+            <pc:docMk/>
+            <pc:sldMk cId="3998171594" sldId="305"/>
+            <ac:spMk id="6" creationId="{82AF1DA3-8DEB-180C-05DF-BBE028A18A6E}"/>
+          </ac:spMkLst>
+        </pc:spChg>
+        <pc:picChg chg="mod">
+          <ac:chgData name="Zied Belhocine" userId="200cc0e2b299676e" providerId="LiveId" clId="{9D5C2755-5B7D-406A-B8B3-AE8FBAA81AB3}" dt="2026-01-09T08:15:37.386" v="718" actId="1076"/>
+          <ac:picMkLst>
+            <pc:docMk/>
+            <pc:sldMk cId="3998171594" sldId="305"/>
+            <ac:picMk id="3" creationId="{E91176A3-5CA2-CCD2-8A6A-6351999522B5}"/>
+          </ac:picMkLst>
+        </pc:picChg>
+      </pc:sldChg>
+      <pc:sldChg chg="modSp mod ord modNotesTx">
+        <pc:chgData name="Zied Belhocine" userId="200cc0e2b299676e" providerId="LiveId" clId="{9D5C2755-5B7D-406A-B8B3-AE8FBAA81AB3}" dt="2026-01-09T15:50:00.756" v="897" actId="1076"/>
+        <pc:sldMkLst>
+          <pc:docMk/>
+          <pc:sldMk cId="2353362535" sldId="306"/>
+        </pc:sldMkLst>
+        <pc:spChg chg="mod">
+          <ac:chgData name="Zied Belhocine" userId="200cc0e2b299676e" providerId="LiveId" clId="{9D5C2755-5B7D-406A-B8B3-AE8FBAA81AB3}" dt="2026-01-09T15:50:00.756" v="897" actId="1076"/>
+          <ac:spMkLst>
+            <pc:docMk/>
+            <pc:sldMk cId="2353362535" sldId="306"/>
+            <ac:spMk id="3" creationId="{EF0CD643-2533-5CD6-2446-CB3E7AD4785B}"/>
+          </ac:spMkLst>
+        </pc:spChg>
+        <pc:spChg chg="mod">
+          <ac:chgData name="Zied Belhocine" userId="200cc0e2b299676e" providerId="LiveId" clId="{9D5C2755-5B7D-406A-B8B3-AE8FBAA81AB3}" dt="2026-01-09T08:15:52.854" v="721" actId="1076"/>
+          <ac:spMkLst>
+            <pc:docMk/>
+            <pc:sldMk cId="2353362535" sldId="306"/>
+            <ac:spMk id="5" creationId="{B638DCEF-0E7B-FF5A-E4B0-9C14906D4760}"/>
+          </ac:spMkLst>
+        </pc:spChg>
+        <pc:picChg chg="mod">
+          <ac:chgData name="Zied Belhocine" userId="200cc0e2b299676e" providerId="LiveId" clId="{9D5C2755-5B7D-406A-B8B3-AE8FBAA81AB3}" dt="2026-01-09T08:16:17.111" v="727" actId="14100"/>
+          <ac:picMkLst>
+            <pc:docMk/>
+            <pc:sldMk cId="2353362535" sldId="306"/>
+            <ac:picMk id="2" creationId="{2CFC9D1A-A636-6112-F50A-51C38D5FEE45}"/>
+          </ac:picMkLst>
+        </pc:picChg>
+      </pc:sldChg>
+      <pc:sldChg chg="modSp mod ord modNotesTx">
+        <pc:chgData name="Zied Belhocine" userId="200cc0e2b299676e" providerId="LiveId" clId="{9D5C2755-5B7D-406A-B8B3-AE8FBAA81AB3}" dt="2026-01-09T15:51:13.286" v="898" actId="20577"/>
         <pc:sldMkLst>
           <pc:docMk/>
           <pc:sldMk cId="1250150470" sldId="308"/>
         </pc:sldMkLst>
         <pc:spChg chg="mod">
-          <ac:chgData name="Zied Belhocine" userId="200cc0e2b299676e" providerId="LiveId" clId="{9D5C2755-5B7D-406A-B8B3-AE8FBAA81AB3}" dt="2026-01-08T11:23:37.438" v="220" actId="20577"/>
+          <ac:chgData name="Zied Belhocine" userId="200cc0e2b299676e" providerId="LiveId" clId="{9D5C2755-5B7D-406A-B8B3-AE8FBAA81AB3}" dt="2026-01-09T15:49:18.203" v="852" actId="20577"/>
           <ac:spMkLst>
             <pc:docMk/>
             <pc:sldMk cId="1250150470" sldId="308"/>
             <ac:spMk id="6" creationId="{672B12A8-6C11-5AE7-B843-F4233C2A8988}"/>
+          </ac:spMkLst>
+        </pc:spChg>
+        <pc:spChg chg="mod">
+          <ac:chgData name="Zied Belhocine" userId="200cc0e2b299676e" providerId="LiveId" clId="{9D5C2755-5B7D-406A-B8B3-AE8FBAA81AB3}" dt="2026-01-09T08:17:17.100" v="740" actId="1076"/>
+          <ac:spMkLst>
+            <pc:docMk/>
+            <pc:sldMk cId="1250150470" sldId="308"/>
+            <ac:spMk id="7" creationId="{9B346097-CD60-B70F-E35D-83B3B4CC3325}"/>
+          </ac:spMkLst>
+        </pc:spChg>
+        <pc:picChg chg="mod">
+          <ac:chgData name="Zied Belhocine" userId="200cc0e2b299676e" providerId="LiveId" clId="{9D5C2755-5B7D-406A-B8B3-AE8FBAA81AB3}" dt="2026-01-09T08:17:22.195" v="741" actId="14100"/>
+          <ac:picMkLst>
+            <pc:docMk/>
+            <pc:sldMk cId="1250150470" sldId="308"/>
+            <ac:picMk id="5" creationId="{29786476-4BDF-EE96-67CE-9A1137BB4B39}"/>
+          </ac:picMkLst>
+        </pc:picChg>
+      </pc:sldChg>
+      <pc:sldChg chg="new del">
+        <pc:chgData name="Zied Belhocine" userId="200cc0e2b299676e" providerId="LiveId" clId="{9D5C2755-5B7D-406A-B8B3-AE8FBAA81AB3}" dt="2026-01-09T15:51:44.127" v="901" actId="47"/>
+        <pc:sldMkLst>
+          <pc:docMk/>
+          <pc:sldMk cId="899877994" sldId="309"/>
+        </pc:sldMkLst>
+      </pc:sldChg>
+      <pc:sldChg chg="modSp new del mod">
+        <pc:chgData name="Zied Belhocine" userId="200cc0e2b299676e" providerId="LiveId" clId="{9D5C2755-5B7D-406A-B8B3-AE8FBAA81AB3}" dt="2026-01-09T15:53:11.703" v="1079" actId="47"/>
+        <pc:sldMkLst>
+          <pc:docMk/>
+          <pc:sldMk cId="411004168" sldId="310"/>
+        </pc:sldMkLst>
+        <pc:spChg chg="mod">
+          <ac:chgData name="Zied Belhocine" userId="200cc0e2b299676e" providerId="LiveId" clId="{9D5C2755-5B7D-406A-B8B3-AE8FBAA81AB3}" dt="2026-01-09T15:51:48.543" v="911" actId="20577"/>
+          <ac:spMkLst>
+            <pc:docMk/>
+            <pc:sldMk cId="411004168" sldId="310"/>
+            <ac:spMk id="2" creationId="{72403460-8D24-9C22-8E78-B54FBC524C0D}"/>
+          </ac:spMkLst>
+        </pc:spChg>
+        <pc:spChg chg="mod">
+          <ac:chgData name="Zied Belhocine" userId="200cc0e2b299676e" providerId="LiveId" clId="{9D5C2755-5B7D-406A-B8B3-AE8FBAA81AB3}" dt="2026-01-09T15:52:30.234" v="1078" actId="20577"/>
+          <ac:spMkLst>
+            <pc:docMk/>
+            <pc:sldMk cId="411004168" sldId="310"/>
+            <ac:spMk id="3" creationId="{308EEAFC-94E5-4D32-8435-59276F008B61}"/>
           </ac:spMkLst>
         </pc:spChg>
       </pc:sldChg>
@@ -298,7 +445,7 @@
             <a:pPr rtl="0"/>
             <a:fld id="{996F3730-8562-4D7F-A2D1-B258C4FC42CB}" type="datetime1">
               <a:rPr lang="fr-FR" smtClean="0"/>
-              <a:t>08/01/2026</a:t>
+              <a:t>09/01/2026</a:t>
             </a:fld>
             <a:endParaRPr lang="fr-FR"/>
           </a:p>
@@ -480,7 +627,7 @@
             <a:fld id="{0F28B237-C4D2-43EE-AC18-AA163EB3D7BC}" type="datetime1">
               <a:rPr lang="fr-FR" smtClean="0"/>
               <a:pPr/>
-              <a:t>08/01/2026</a:t>
+              <a:t>09/01/2026</a:t>
             </a:fld>
             <a:endParaRPr lang="fr-FR" dirty="0"/>
           </a:p>
@@ -880,7 +1027,30 @@
           <a:bodyPr/>
           <a:lstStyle/>
           <a:p>
-            <a:endParaRPr lang="fr-FR"/>
+            <a:pPr marL="0" marR="0" lvl="0" indent="0" algn="l" defTabSz="914400" rtl="0" eaLnBrk="1" fontAlgn="auto" latinLnBrk="0" hangingPunct="1">
+              <a:lnSpc>
+                <a:spcPct val="100000"/>
+              </a:lnSpc>
+              <a:spcBef>
+                <a:spcPts val="0"/>
+              </a:spcBef>
+              <a:spcAft>
+                <a:spcPts val="0"/>
+              </a:spcAft>
+              <a:buClrTx/>
+              <a:buSzTx/>
+              <a:buFontTx/>
+              <a:buNone/>
+              <a:tabLst/>
+              <a:defRPr/>
+            </a:pPr>
+            <a:r>
+              <a:rPr lang="fr-FR" sz="1000" dirty="0"/>
+              <a:t>L’année dernière, nous avons tourné la page du High Tech pour concentrer nos efforts sur la nourriture et les biens de consommation (juillet 2019). Cet arrêt du high tech a mécaniquement fait baisser notre chiffre total. Cependant l’évolution de la partie nourriture est très encourageante.</a:t>
+            </a:r>
+          </a:p>
+          <a:p>
+            <a:endParaRPr lang="fr-FR" dirty="0"/>
           </a:p>
         </p:txBody>
       </p:sp>
@@ -965,7 +1135,30 @@
           <a:bodyPr/>
           <a:lstStyle/>
           <a:p>
-            <a:endParaRPr lang="fr-FR"/>
+            <a:pPr marL="0" marR="0" lvl="0" indent="0" algn="l" defTabSz="914400" rtl="0" eaLnBrk="1" fontAlgn="auto" latinLnBrk="0" hangingPunct="1">
+              <a:lnSpc>
+                <a:spcPct val="100000"/>
+              </a:lnSpc>
+              <a:spcBef>
+                <a:spcPts val="0"/>
+              </a:spcBef>
+              <a:spcAft>
+                <a:spcPts val="0"/>
+              </a:spcAft>
+              <a:buClrTx/>
+              <a:buSzTx/>
+              <a:buFontTx/>
+              <a:buNone/>
+              <a:tabLst/>
+              <a:defRPr/>
+            </a:pPr>
+            <a:r>
+              <a:rPr lang="fr-FR" dirty="0"/>
+              <a:t>Cela a eu un impact fort sur le taux de conversion qui est divisé par deux entre juillet et février (0,10 à 0,05). Néanmoins, il y a une tendance de stabilisation sur les deux derniers mois et décroit moins rapidement que le taux de conversion augmente, c’est bon signe.</a:t>
+            </a:r>
+          </a:p>
+          <a:p>
+            <a:endParaRPr lang="fr-FR" dirty="0"/>
           </a:p>
         </p:txBody>
       </p:sp>
@@ -996,7 +1189,7 @@
     </p:spTree>
     <p:extLst>
       <p:ext uri="{BB962C8B-B14F-4D97-AF65-F5344CB8AC3E}">
-        <p14:creationId xmlns:p14="http://schemas.microsoft.com/office/powerpoint/2010/main" val="1408687645"/>
+        <p14:creationId xmlns:p14="http://schemas.microsoft.com/office/powerpoint/2010/main" val="2640048239"/>
       </p:ext>
     </p:extLst>
   </p:cSld>
@@ -1050,7 +1243,27 @@
           <a:bodyPr/>
           <a:lstStyle/>
           <a:p>
-            <a:endParaRPr lang="fr-FR"/>
+            <a:pPr marL="0" marR="0" lvl="0" indent="0" algn="l" defTabSz="914400" rtl="0" eaLnBrk="1" fontAlgn="auto" latinLnBrk="0" hangingPunct="1">
+              <a:lnSpc>
+                <a:spcPct val="100000"/>
+              </a:lnSpc>
+              <a:spcBef>
+                <a:spcPts val="0"/>
+              </a:spcBef>
+              <a:spcAft>
+                <a:spcPts val="0"/>
+              </a:spcAft>
+              <a:buClrTx/>
+              <a:buSzTx/>
+              <a:buFontTx/>
+              <a:buNone/>
+              <a:tabLst/>
+              <a:defRPr/>
+            </a:pPr>
+            <a:r>
+              <a:rPr lang="fr-FR" dirty="0"/>
+              <a:t>On peut voir ici que plus ils passent de temps sur notre site, plus ils vont avoir un panier élevé. </a:t>
+            </a:r>
           </a:p>
         </p:txBody>
       </p:sp>
@@ -1081,7 +1294,7 @@
     </p:spTree>
     <p:extLst>
       <p:ext uri="{BB962C8B-B14F-4D97-AF65-F5344CB8AC3E}">
-        <p14:creationId xmlns:p14="http://schemas.microsoft.com/office/powerpoint/2010/main" val="2640048239"/>
+        <p14:creationId xmlns:p14="http://schemas.microsoft.com/office/powerpoint/2010/main" val="292140105"/>
       </p:ext>
     </p:extLst>
   </p:cSld>
@@ -1135,7 +1348,30 @@
           <a:bodyPr/>
           <a:lstStyle/>
           <a:p>
-            <a:endParaRPr lang="fr-FR"/>
+            <a:pPr marL="0" marR="0" lvl="0" indent="0" algn="l" defTabSz="914400" rtl="0" eaLnBrk="1" fontAlgn="auto" latinLnBrk="0" hangingPunct="1">
+              <a:lnSpc>
+                <a:spcPct val="100000"/>
+              </a:lnSpc>
+              <a:spcBef>
+                <a:spcPts val="0"/>
+              </a:spcBef>
+              <a:spcAft>
+                <a:spcPts val="0"/>
+              </a:spcAft>
+              <a:buClrTx/>
+              <a:buSzTx/>
+              <a:buFontTx/>
+              <a:buNone/>
+              <a:tabLst/>
+              <a:defRPr/>
+            </a:pPr>
+            <a:r>
+              <a:rPr lang="fr-FR" dirty="0"/>
+              <a:t>On constate par ailleurs que ce changement de stratégie entraine des changements de comportements chez nos clients. Ceux-ci ont des profils beaucoup plus variés. Ils sont notamment beaucoup plus nombreux à passer moins de 6 minutes pour faire leurs achats. </a:t>
+            </a:r>
+          </a:p>
+          <a:p>
+            <a:endParaRPr lang="fr-FR" dirty="0"/>
           </a:p>
         </p:txBody>
       </p:sp>
@@ -1220,7 +1456,30 @@
           <a:bodyPr/>
           <a:lstStyle/>
           <a:p>
-            <a:endParaRPr lang="fr-FR"/>
+            <a:pPr marL="0" marR="0" lvl="0" indent="0" algn="l" defTabSz="914400" rtl="0" eaLnBrk="1" fontAlgn="auto" latinLnBrk="0" hangingPunct="1">
+              <a:lnSpc>
+                <a:spcPct val="100000"/>
+              </a:lnSpc>
+              <a:spcBef>
+                <a:spcPts val="0"/>
+              </a:spcBef>
+              <a:spcAft>
+                <a:spcPts val="0"/>
+              </a:spcAft>
+              <a:buClrTx/>
+              <a:buSzTx/>
+              <a:buFontTx/>
+              <a:buNone/>
+              <a:tabLst/>
+              <a:defRPr/>
+            </a:pPr>
+            <a:r>
+              <a:rPr lang="fr-FR" dirty="0"/>
+              <a:t>La conséquence de cela a été une forte augmentation du nombre de visites et de ventes dès cette transition (juillet 2019). Le nombre de visite augmente d’ailleurs de manière exponentielle (presque +150k entre janvier et février ~ +30% ).</a:t>
+            </a:r>
+          </a:p>
+          <a:p>
+            <a:endParaRPr lang="fr-FR" dirty="0"/>
           </a:p>
         </p:txBody>
       </p:sp>
@@ -1251,7 +1510,7 @@
     </p:spTree>
     <p:extLst>
       <p:ext uri="{BB962C8B-B14F-4D97-AF65-F5344CB8AC3E}">
-        <p14:creationId xmlns:p14="http://schemas.microsoft.com/office/powerpoint/2010/main" val="292140105"/>
+        <p14:creationId xmlns:p14="http://schemas.microsoft.com/office/powerpoint/2010/main" val="1408687645"/>
       </p:ext>
     </p:extLst>
   </p:cSld>
@@ -16857,8 +17116,8 @@
         </p:blipFill>
         <p:spPr>
           <a:xfrm>
-            <a:off x="5358178" y="1298604"/>
-            <a:ext cx="6126479" cy="4765040"/>
+            <a:off x="1801472" y="313235"/>
+            <a:ext cx="8589055" cy="5719236"/>
           </a:xfrm>
           <a:prstGeom prst="rect">
             <a:avLst/>
@@ -16879,8 +17138,8 @@
         </p:nvSpPr>
         <p:spPr>
           <a:xfrm>
-            <a:off x="838200" y="2679194"/>
-            <a:ext cx="4028574" cy="2308324"/>
+            <a:off x="2136301" y="5621435"/>
+            <a:ext cx="8181109" cy="923330"/>
           </a:xfrm>
           <a:prstGeom prst="rect">
             <a:avLst/>
@@ -16893,10 +17152,24 @@
           </a:bodyPr>
           <a:lstStyle/>
           <a:p>
-            <a:pPr algn="just"/>
+            <a:pPr algn="ctr"/>
             <a:r>
               <a:rPr lang="fr-FR" dirty="0"/>
-              <a:t>L’année dernière, nous avons tourné la page du High Tech pour concentrer nos efforts sur la nourriture et les biens de consommation (juillet 2019). Cet arrêt du high tech a mécaniquement fait baisser notre chiffre total. Cependant l’évolution de la partie nourriture est très encourageante.</a:t>
+              <a:t>Arrêt du high tech a mécaniquement fait baisser notre chiffre total. </a:t>
+            </a:r>
+          </a:p>
+          <a:p>
+            <a:pPr algn="ctr"/>
+            <a:r>
+              <a:rPr lang="fr-FR" dirty="0"/>
+              <a:t>Biens de conso. Reste stable ~200k€/mois</a:t>
+            </a:r>
+          </a:p>
+          <a:p>
+            <a:pPr algn="ctr"/>
+            <a:r>
+              <a:rPr lang="fr-FR" dirty="0"/>
+              <a:t>Très forte évolution de la partie nourriture (~+100k entre janvier et février ~+25%)</a:t>
             </a:r>
           </a:p>
         </p:txBody>
@@ -16919,8 +17192,8 @@
         </p:nvSpPr>
         <p:spPr>
           <a:xfrm>
-            <a:off x="838200" y="365125"/>
-            <a:ext cx="10515600" cy="1325563"/>
+            <a:off x="969056" y="55749"/>
+            <a:ext cx="10515600" cy="923330"/>
           </a:xfrm>
         </p:spPr>
         <p:txBody>
@@ -17032,10 +17305,10 @@
       </p:sp>
       <p:pic>
         <p:nvPicPr>
-          <p:cNvPr id="2" name="Image 1">
-            <a:extLst>
-              <a:ext uri="{FF2B5EF4-FFF2-40B4-BE49-F238E27FC236}">
-                <a16:creationId xmlns:a16="http://schemas.microsoft.com/office/drawing/2014/main" id="{2415FE7D-904B-B539-B403-F92F79825ED8}"/>
+          <p:cNvPr id="3" name="Image 2">
+            <a:extLst>
+              <a:ext uri="{FF2B5EF4-FFF2-40B4-BE49-F238E27FC236}">
+                <a16:creationId xmlns:a16="http://schemas.microsoft.com/office/drawing/2014/main" id="{E91176A3-5CA2-CCD2-8A6A-6351999522B5}"/>
               </a:ext>
             </a:extLst>
           </p:cNvPr>
@@ -17052,8 +17325,8 @@
         </p:blipFill>
         <p:spPr>
           <a:xfrm>
-            <a:off x="4974592" y="1767115"/>
-            <a:ext cx="5819501" cy="4526279"/>
+            <a:off x="2101057" y="462373"/>
+            <a:ext cx="7989885" cy="5998968"/>
           </a:xfrm>
           <a:prstGeom prst="rect">
             <a:avLst/>
@@ -17062,10 +17335,10 @@
       </p:pic>
       <p:sp>
         <p:nvSpPr>
-          <p:cNvPr id="3" name="ZoneTexte 2">
-            <a:extLst>
-              <a:ext uri="{FF2B5EF4-FFF2-40B4-BE49-F238E27FC236}">
-                <a16:creationId xmlns:a16="http://schemas.microsoft.com/office/drawing/2014/main" id="{E503D5C8-EABC-8DB3-766D-2D8D43C29F2E}"/>
+          <p:cNvPr id="5" name="ZoneTexte 4">
+            <a:extLst>
+              <a:ext uri="{FF2B5EF4-FFF2-40B4-BE49-F238E27FC236}">
+                <a16:creationId xmlns:a16="http://schemas.microsoft.com/office/drawing/2014/main" id="{5F2CDB22-66E5-2C01-0C7C-51F41FB5CFD6}"/>
               </a:ext>
             </a:extLst>
           </p:cNvPr>
@@ -17074,8 +17347,8 @@
         </p:nvSpPr>
         <p:spPr>
           <a:xfrm>
-            <a:off x="724989" y="3014593"/>
-            <a:ext cx="4003765" cy="2031325"/>
+            <a:off x="2357728" y="6123543"/>
+            <a:ext cx="8289967" cy="369332"/>
           </a:xfrm>
           <a:prstGeom prst="rect">
             <a:avLst/>
@@ -17091,17 +17364,17 @@
             <a:pPr algn="just"/>
             <a:r>
               <a:rPr lang="fr-FR" dirty="0"/>
-              <a:t>La conséquence de cela a été une forte augmentation du nombre de visites et de ventes dès cette transition (juillet 2019). Le nombre de visite augmente d’ailleurs de manière exponentielle (presque +150k entre janvier et février ~ +30% ).</a:t>
-            </a:r>
-          </a:p>
-        </p:txBody>
-      </p:sp>
-      <p:sp>
-        <p:nvSpPr>
-          <p:cNvPr id="5" name="Titre 1">
-            <a:extLst>
-              <a:ext uri="{FF2B5EF4-FFF2-40B4-BE49-F238E27FC236}">
-                <a16:creationId xmlns:a16="http://schemas.microsoft.com/office/drawing/2014/main" id="{4F487A6A-202B-34F2-3157-3A0DB7CFF017}"/>
+              <a:t>Taux de conversion qui est divisé par deux entre juillet et février (0,10 à 0,05). </a:t>
+            </a:r>
+          </a:p>
+        </p:txBody>
+      </p:sp>
+      <p:sp>
+        <p:nvSpPr>
+          <p:cNvPr id="6" name="Titre 1">
+            <a:extLst>
+              <a:ext uri="{FF2B5EF4-FFF2-40B4-BE49-F238E27FC236}">
+                <a16:creationId xmlns:a16="http://schemas.microsoft.com/office/drawing/2014/main" id="{82AF1DA3-8DEB-180C-05DF-BBE028A18A6E}"/>
               </a:ext>
             </a:extLst>
           </p:cNvPr>
@@ -17114,8 +17387,8 @@
         </p:nvSpPr>
         <p:spPr>
           <a:xfrm>
-            <a:off x="838200" y="365125"/>
-            <a:ext cx="10515600" cy="1325563"/>
+            <a:off x="688848" y="72736"/>
+            <a:ext cx="10515600" cy="942543"/>
           </a:xfrm>
         </p:spPr>
         <p:txBody>
@@ -17124,17 +17397,17 @@
           <a:p>
             <a:r>
               <a:rPr lang="fr-FR" dirty="0"/>
-              <a:t>Évolution du nombre de ventes et de visites sur le site au cours des 12 derniers mois</a:t>
+              <a:t>Évolution du taux de conversion au cours des 12 derniers mois</a:t>
             </a:r>
           </a:p>
         </p:txBody>
       </p:sp>
       <p:pic>
         <p:nvPicPr>
-          <p:cNvPr id="6" name="Image 5" descr="Une image contenant texte, Police, capture d’écran, logo&#10;&#10;Le contenu généré par l’IA peut être incorrect.">
-            <a:extLst>
-              <a:ext uri="{FF2B5EF4-FFF2-40B4-BE49-F238E27FC236}">
-                <a16:creationId xmlns:a16="http://schemas.microsoft.com/office/drawing/2014/main" id="{0512DA33-A46C-9CBD-2F91-B8108D6CF218}"/>
+          <p:cNvPr id="7" name="Image 6" descr="Une image contenant texte, Police, capture d’écran, logo&#10;&#10;Le contenu généré par l’IA peut être incorrect.">
+            <a:extLst>
+              <a:ext uri="{FF2B5EF4-FFF2-40B4-BE49-F238E27FC236}">
+                <a16:creationId xmlns:a16="http://schemas.microsoft.com/office/drawing/2014/main" id="{9439E07F-D4F2-2CBD-3578-0B61A7D1B602}"/>
               </a:ext>
             </a:extLst>
           </p:cNvPr>
@@ -17162,7 +17435,7 @@
     </p:spTree>
     <p:extLst>
       <p:ext uri="{BB962C8B-B14F-4D97-AF65-F5344CB8AC3E}">
-        <p14:creationId xmlns:p14="http://schemas.microsoft.com/office/powerpoint/2010/main" val="3063745067"/>
+        <p14:creationId xmlns:p14="http://schemas.microsoft.com/office/powerpoint/2010/main" val="3998171594"/>
       </p:ext>
     </p:extLst>
   </p:cSld>
@@ -17227,10 +17500,10 @@
       </p:sp>
       <p:pic>
         <p:nvPicPr>
-          <p:cNvPr id="3" name="Image 2">
-            <a:extLst>
-              <a:ext uri="{FF2B5EF4-FFF2-40B4-BE49-F238E27FC236}">
-                <a16:creationId xmlns:a16="http://schemas.microsoft.com/office/drawing/2014/main" id="{E91176A3-5CA2-CCD2-8A6A-6351999522B5}"/>
+          <p:cNvPr id="5" name="Image 4" descr="Une image contenant capture d’écran, visualisation&#10;&#10;Le contenu généré par l’IA peut être incorrect.">
+            <a:extLst>
+              <a:ext uri="{FF2B5EF4-FFF2-40B4-BE49-F238E27FC236}">
+                <a16:creationId xmlns:a16="http://schemas.microsoft.com/office/drawing/2014/main" id="{29786476-4BDF-EE96-67CE-9A1137BB4B39}"/>
               </a:ext>
             </a:extLst>
           </p:cNvPr>
@@ -17247,8 +17520,8 @@
         </p:blipFill>
         <p:spPr>
           <a:xfrm>
-            <a:off x="5346152" y="1626327"/>
-            <a:ext cx="5946688" cy="4464894"/>
+            <a:off x="2125160" y="464179"/>
+            <a:ext cx="7751180" cy="5863885"/>
           </a:xfrm>
           <a:prstGeom prst="rect">
             <a:avLst/>
@@ -17257,10 +17530,10 @@
       </p:pic>
       <p:sp>
         <p:nvSpPr>
-          <p:cNvPr id="5" name="ZoneTexte 4">
-            <a:extLst>
-              <a:ext uri="{FF2B5EF4-FFF2-40B4-BE49-F238E27FC236}">
-                <a16:creationId xmlns:a16="http://schemas.microsoft.com/office/drawing/2014/main" id="{5F2CDB22-66E5-2C01-0C7C-51F41FB5CFD6}"/>
+          <p:cNvPr id="6" name="ZoneTexte 5">
+            <a:extLst>
+              <a:ext uri="{FF2B5EF4-FFF2-40B4-BE49-F238E27FC236}">
+                <a16:creationId xmlns:a16="http://schemas.microsoft.com/office/drawing/2014/main" id="{672B12A8-6C11-5AE7-B843-F4233C2A8988}"/>
               </a:ext>
             </a:extLst>
           </p:cNvPr>
@@ -17269,8 +17542,8 @@
         </p:nvSpPr>
         <p:spPr>
           <a:xfrm>
-            <a:off x="957942" y="2704612"/>
-            <a:ext cx="3966754" cy="2308324"/>
+            <a:off x="2315660" y="6106886"/>
+            <a:ext cx="7560680" cy="646331"/>
           </a:xfrm>
           <a:prstGeom prst="rect">
             <a:avLst/>
@@ -17283,20 +17556,27 @@
           </a:bodyPr>
           <a:lstStyle/>
           <a:p>
-            <a:pPr algn="just"/>
+            <a:pPr algn="ctr"/>
             <a:r>
               <a:rPr lang="fr-FR" dirty="0"/>
-              <a:t>Cela a eu un impact fort sur le taux de conversion qui est divisé par deux entre juillet et février (0,10 à 0,05). Néanmoins, il y a une tendance de stabilisation sur les deux derniers mois et décroit moins rapidement que le taux de conversion augmente, c’est bon signe.</a:t>
-            </a:r>
-          </a:p>
-        </p:txBody>
-      </p:sp>
-      <p:sp>
-        <p:nvSpPr>
-          <p:cNvPr id="6" name="Titre 1">
-            <a:extLst>
-              <a:ext uri="{FF2B5EF4-FFF2-40B4-BE49-F238E27FC236}">
-                <a16:creationId xmlns:a16="http://schemas.microsoft.com/office/drawing/2014/main" id="{82AF1DA3-8DEB-180C-05DF-BBE028A18A6E}"/>
+              <a:t>Forte concentration de paniers autour de 40€. </a:t>
+            </a:r>
+          </a:p>
+          <a:p>
+            <a:pPr algn="ctr"/>
+            <a:r>
+              <a:rPr lang="fr-FR" dirty="0"/>
+              <a:t>Plus ils passent de temps sur notre site, plus ils vont avoir un panier élevé. </a:t>
+            </a:r>
+          </a:p>
+        </p:txBody>
+      </p:sp>
+      <p:sp>
+        <p:nvSpPr>
+          <p:cNvPr id="7" name="Titre 1">
+            <a:extLst>
+              <a:ext uri="{FF2B5EF4-FFF2-40B4-BE49-F238E27FC236}">
+                <a16:creationId xmlns:a16="http://schemas.microsoft.com/office/drawing/2014/main" id="{9B346097-CD60-B70F-E35D-83B3B4CC3325}"/>
               </a:ext>
             </a:extLst>
           </p:cNvPr>
@@ -17309,8 +17589,8 @@
         </p:nvSpPr>
         <p:spPr>
           <a:xfrm>
-            <a:off x="838200" y="365125"/>
-            <a:ext cx="10515600" cy="1325563"/>
+            <a:off x="842211" y="228699"/>
+            <a:ext cx="10515600" cy="911271"/>
           </a:xfrm>
         </p:spPr>
         <p:txBody>
@@ -17319,17 +17599,17 @@
           <a:p>
             <a:r>
               <a:rPr lang="fr-FR" dirty="0"/>
-              <a:t>Évolution du taux de conversion au cours des 12 derniers mois</a:t>
+              <a:t>Comparaison entre le temps passé sur le site et le panier moyen</a:t>
             </a:r>
           </a:p>
         </p:txBody>
       </p:sp>
       <p:pic>
         <p:nvPicPr>
-          <p:cNvPr id="7" name="Image 6" descr="Une image contenant texte, Police, capture d’écran, logo&#10;&#10;Le contenu généré par l’IA peut être incorrect.">
-            <a:extLst>
-              <a:ext uri="{FF2B5EF4-FFF2-40B4-BE49-F238E27FC236}">
-                <a16:creationId xmlns:a16="http://schemas.microsoft.com/office/drawing/2014/main" id="{9439E07F-D4F2-2CBD-3578-0B61A7D1B602}"/>
+          <p:cNvPr id="8" name="Image 7" descr="Une image contenant texte, Police, capture d’écran, logo&#10;&#10;Le contenu généré par l’IA peut être incorrect.">
+            <a:extLst>
+              <a:ext uri="{FF2B5EF4-FFF2-40B4-BE49-F238E27FC236}">
+                <a16:creationId xmlns:a16="http://schemas.microsoft.com/office/drawing/2014/main" id="{A4C1BADD-9F05-A50E-1952-FF83019CB9ED}"/>
               </a:ext>
             </a:extLst>
           </p:cNvPr>
@@ -17357,7 +17637,7 @@
     </p:spTree>
     <p:extLst>
       <p:ext uri="{BB962C8B-B14F-4D97-AF65-F5344CB8AC3E}">
-        <p14:creationId xmlns:p14="http://schemas.microsoft.com/office/powerpoint/2010/main" val="3998171594"/>
+        <p14:creationId xmlns:p14="http://schemas.microsoft.com/office/powerpoint/2010/main" val="1250150470"/>
       </p:ext>
     </p:extLst>
   </p:cSld>
@@ -17442,8 +17722,8 @@
         </p:blipFill>
         <p:spPr>
           <a:xfrm>
-            <a:off x="5492864" y="1859339"/>
-            <a:ext cx="5711584" cy="4442344"/>
+            <a:off x="2171237" y="498763"/>
+            <a:ext cx="7796230" cy="5486401"/>
           </a:xfrm>
           <a:prstGeom prst="rect">
             <a:avLst/>
@@ -17464,8 +17744,8 @@
         </p:nvSpPr>
         <p:spPr>
           <a:xfrm>
-            <a:off x="838200" y="3069772"/>
-            <a:ext cx="4347755" cy="2031325"/>
+            <a:off x="1242352" y="5541453"/>
+            <a:ext cx="9346563" cy="1200329"/>
           </a:xfrm>
           <a:prstGeom prst="rect">
             <a:avLst/>
@@ -17478,10 +17758,21 @@
           </a:bodyPr>
           <a:lstStyle/>
           <a:p>
-            <a:pPr algn="just"/>
+            <a:pPr algn="ctr"/>
             <a:r>
               <a:rPr lang="fr-FR" dirty="0"/>
-              <a:t>On constate par ailleurs que ce changement de stratégie entraine des changements de comportements chez nos clients. Ceux-ci ont des profils beaucoup plus variés. Ils sont notamment beaucoup plus nombreux à passer moins de 6 minutes pour faire leurs achats.</a:t>
+              <a:t>Variance augmente et les clients sont beaucoup plus nombreux à passer moins de 6 minutes pour faire leurs achats.</a:t>
+            </a:r>
+          </a:p>
+          <a:p>
+            <a:pPr algn="ctr"/>
+            <a:endParaRPr lang="fr-FR" dirty="0"/>
+          </a:p>
+          <a:p>
+            <a:pPr algn="ctr"/>
+            <a:r>
+              <a:rPr lang="fr-FR" dirty="0"/>
+              <a:t>Revoir la segmentation de notre base client est une priorité.</a:t>
             </a:r>
           </a:p>
         </p:txBody>
@@ -17504,8 +17795,8 @@
         </p:nvSpPr>
         <p:spPr>
           <a:xfrm>
-            <a:off x="838200" y="365125"/>
-            <a:ext cx="10515600" cy="1325563"/>
+            <a:off x="838200" y="116218"/>
+            <a:ext cx="10515600" cy="880197"/>
           </a:xfrm>
         </p:spPr>
         <p:txBody>
@@ -17617,10 +17908,10 @@
       </p:sp>
       <p:pic>
         <p:nvPicPr>
-          <p:cNvPr id="5" name="Image 4" descr="Une image contenant capture d’écran, visualisation&#10;&#10;Le contenu généré par l’IA peut être incorrect.">
-            <a:extLst>
-              <a:ext uri="{FF2B5EF4-FFF2-40B4-BE49-F238E27FC236}">
-                <a16:creationId xmlns:a16="http://schemas.microsoft.com/office/drawing/2014/main" id="{29786476-4BDF-EE96-67CE-9A1137BB4B39}"/>
+          <p:cNvPr id="2" name="Image 1">
+            <a:extLst>
+              <a:ext uri="{FF2B5EF4-FFF2-40B4-BE49-F238E27FC236}">
+                <a16:creationId xmlns:a16="http://schemas.microsoft.com/office/drawing/2014/main" id="{2415FE7D-904B-B539-B403-F92F79825ED8}"/>
               </a:ext>
             </a:extLst>
           </p:cNvPr>
@@ -17637,8 +17928,8 @@
         </p:blipFill>
         <p:spPr>
           <a:xfrm>
-            <a:off x="5367130" y="1690688"/>
-            <a:ext cx="5677968" cy="4416198"/>
+            <a:off x="1452294" y="468058"/>
+            <a:ext cx="9287412" cy="5921884"/>
           </a:xfrm>
           <a:prstGeom prst="rect">
             <a:avLst/>
@@ -17647,10 +17938,10 @@
       </p:pic>
       <p:sp>
         <p:nvSpPr>
-          <p:cNvPr id="6" name="ZoneTexte 5">
-            <a:extLst>
-              <a:ext uri="{FF2B5EF4-FFF2-40B4-BE49-F238E27FC236}">
-                <a16:creationId xmlns:a16="http://schemas.microsoft.com/office/drawing/2014/main" id="{672B12A8-6C11-5AE7-B843-F4233C2A8988}"/>
+          <p:cNvPr id="3" name="ZoneTexte 2">
+            <a:extLst>
+              <a:ext uri="{FF2B5EF4-FFF2-40B4-BE49-F238E27FC236}">
+                <a16:creationId xmlns:a16="http://schemas.microsoft.com/office/drawing/2014/main" id="{E503D5C8-EABC-8DB3-766D-2D8D43C29F2E}"/>
               </a:ext>
             </a:extLst>
           </p:cNvPr>
@@ -17659,8 +17950,8 @@
         </p:nvSpPr>
         <p:spPr>
           <a:xfrm>
-            <a:off x="790776" y="2953012"/>
-            <a:ext cx="4576354" cy="2308324"/>
+            <a:off x="974683" y="6020610"/>
+            <a:ext cx="10515600" cy="369332"/>
           </a:xfrm>
           <a:prstGeom prst="rect">
             <a:avLst/>
@@ -17673,20 +17964,20 @@
           </a:bodyPr>
           <a:lstStyle/>
           <a:p>
-            <a:pPr algn="just"/>
+            <a:pPr algn="ctr"/>
             <a:r>
               <a:rPr lang="fr-FR" dirty="0"/>
-              <a:t>On peut voir ici que plus ils passent de temps sur notre site, plus ils vont avoir un panier élevé. Ma proposition est donc simple et consiste à inciter nos clients à passer plus de temps pour faire leurs achats (donc dépenser plus) tout en améliorant notre taux de conversion grâce au flux exponentiel de visiteurs. </a:t>
-            </a:r>
-          </a:p>
-        </p:txBody>
-      </p:sp>
-      <p:sp>
-        <p:nvSpPr>
-          <p:cNvPr id="7" name="Titre 1">
-            <a:extLst>
-              <a:ext uri="{FF2B5EF4-FFF2-40B4-BE49-F238E27FC236}">
-                <a16:creationId xmlns:a16="http://schemas.microsoft.com/office/drawing/2014/main" id="{9B346097-CD60-B70F-E35D-83B3B4CC3325}"/>
+              <a:t>Forte augmentation du nombre de visites et de ventes dès cette transition (juillet 2019). </a:t>
+            </a:r>
+          </a:p>
+        </p:txBody>
+      </p:sp>
+      <p:sp>
+        <p:nvSpPr>
+          <p:cNvPr id="5" name="Titre 1">
+            <a:extLst>
+              <a:ext uri="{FF2B5EF4-FFF2-40B4-BE49-F238E27FC236}">
+                <a16:creationId xmlns:a16="http://schemas.microsoft.com/office/drawing/2014/main" id="{4F487A6A-202B-34F2-3157-3A0DB7CFF017}"/>
               </a:ext>
             </a:extLst>
           </p:cNvPr>
@@ -17699,27 +17990,29 @@
         </p:nvSpPr>
         <p:spPr>
           <a:xfrm>
-            <a:off x="838200" y="365125"/>
-            <a:ext cx="10515600" cy="1325563"/>
-          </a:xfrm>
-        </p:spPr>
-        <p:txBody>
-          <a:bodyPr/>
+            <a:off x="842211" y="6393"/>
+            <a:ext cx="10515600" cy="923330"/>
+          </a:xfrm>
+        </p:spPr>
+        <p:txBody>
+          <a:bodyPr>
+            <a:normAutofit/>
+          </a:bodyPr>
           <a:lstStyle/>
           <a:p>
             <a:r>
               <a:rPr lang="fr-FR" dirty="0"/>
-              <a:t>Comparaison entre le temps passé sur le site et le panier moyen</a:t>
+              <a:t>Évolution du nombre de ventes et de visites sur le site au cours des 12 derniers mois</a:t>
             </a:r>
           </a:p>
         </p:txBody>
       </p:sp>
       <p:pic>
         <p:nvPicPr>
-          <p:cNvPr id="8" name="Image 7" descr="Une image contenant texte, Police, capture d’écran, logo&#10;&#10;Le contenu généré par l’IA peut être incorrect.">
-            <a:extLst>
-              <a:ext uri="{FF2B5EF4-FFF2-40B4-BE49-F238E27FC236}">
-                <a16:creationId xmlns:a16="http://schemas.microsoft.com/office/drawing/2014/main" id="{A4C1BADD-9F05-A50E-1952-FF83019CB9ED}"/>
+          <p:cNvPr id="6" name="Image 5" descr="Une image contenant texte, Police, capture d’écran, logo&#10;&#10;Le contenu généré par l’IA peut être incorrect.">
+            <a:extLst>
+              <a:ext uri="{FF2B5EF4-FFF2-40B4-BE49-F238E27FC236}">
+                <a16:creationId xmlns:a16="http://schemas.microsoft.com/office/drawing/2014/main" id="{0512DA33-A46C-9CBD-2F91-B8108D6CF218}"/>
               </a:ext>
             </a:extLst>
           </p:cNvPr>
@@ -17747,7 +18040,7 @@
     </p:spTree>
     <p:extLst>
       <p:ext uri="{BB962C8B-B14F-4D97-AF65-F5344CB8AC3E}">
-        <p14:creationId xmlns:p14="http://schemas.microsoft.com/office/powerpoint/2010/main" val="1250150470"/>
+        <p14:creationId xmlns:p14="http://schemas.microsoft.com/office/powerpoint/2010/main" val="3063745067"/>
       </p:ext>
     </p:extLst>
   </p:cSld>

</xml_diff>

<commit_message>
MAJ 15/01/25 projet 1 et 2
</commit_message>
<xml_diff>
--- a/Data_Analyst/Projet_2/rapport mensuel des actions marketing.pptx
+++ b/Data_Analyst/Projet_2/rapport mensuel des actions marketing.pptx
@@ -5,19 +5,20 @@
     <p:sldMasterId id="2147483666" r:id="rId4"/>
   </p:sldMasterIdLst>
   <p:notesMasterIdLst>
-    <p:notesMasterId r:id="rId12"/>
+    <p:notesMasterId r:id="rId13"/>
   </p:notesMasterIdLst>
   <p:handoutMasterIdLst>
-    <p:handoutMasterId r:id="rId13"/>
+    <p:handoutMasterId r:id="rId14"/>
   </p:handoutMasterIdLst>
   <p:sldIdLst>
     <p:sldId id="256" r:id="rId5"/>
-    <p:sldId id="300" r:id="rId6"/>
-    <p:sldId id="305" r:id="rId7"/>
-    <p:sldId id="308" r:id="rId8"/>
-    <p:sldId id="306" r:id="rId9"/>
-    <p:sldId id="304" r:id="rId10"/>
-    <p:sldId id="276" r:id="rId11"/>
+    <p:sldId id="309" r:id="rId6"/>
+    <p:sldId id="304" r:id="rId7"/>
+    <p:sldId id="305" r:id="rId8"/>
+    <p:sldId id="308" r:id="rId9"/>
+    <p:sldId id="306" r:id="rId10"/>
+    <p:sldId id="300" r:id="rId11"/>
+    <p:sldId id="276" r:id="rId12"/>
   </p:sldIdLst>
   <p:sldSz cx="12192000" cy="6858000"/>
   <p:notesSz cx="6858000" cy="9144000"/>
@@ -155,12 +156,12 @@
   <pc:docChgLst>
     <pc:chgData name="Zied Belhocine" userId="200cc0e2b299676e" providerId="LiveId" clId="{9D5C2755-5B7D-406A-B8B3-AE8FBAA81AB3}"/>
     <pc:docChg chg="undo custSel addSld delSld modSld sldOrd">
-      <pc:chgData name="Zied Belhocine" userId="200cc0e2b299676e" providerId="LiveId" clId="{9D5C2755-5B7D-406A-B8B3-AE8FBAA81AB3}" dt="2026-01-09T16:22:46.845" v="1126" actId="20577"/>
+      <pc:chgData name="Zied Belhocine" userId="200cc0e2b299676e" providerId="LiveId" clId="{9D5C2755-5B7D-406A-B8B3-AE8FBAA81AB3}" dt="2026-01-15T12:41:22.035" v="1137"/>
       <pc:docMkLst>
         <pc:docMk/>
       </pc:docMkLst>
       <pc:sldChg chg="modSp mod ord modNotesTx">
-        <pc:chgData name="Zied Belhocine" userId="200cc0e2b299676e" providerId="LiveId" clId="{9D5C2755-5B7D-406A-B8B3-AE8FBAA81AB3}" dt="2026-01-09T16:22:46.845" v="1126" actId="20577"/>
+        <pc:chgData name="Zied Belhocine" userId="200cc0e2b299676e" providerId="LiveId" clId="{9D5C2755-5B7D-406A-B8B3-AE8FBAA81AB3}" dt="2026-01-15T12:38:03.386" v="1134"/>
         <pc:sldMkLst>
           <pc:docMk/>
           <pc:sldMk cId="4153042215" sldId="300"/>
@@ -190,8 +191,8 @@
           </ac:picMkLst>
         </pc:picChg>
       </pc:sldChg>
-      <pc:sldChg chg="modSp mod modNotesTx">
-        <pc:chgData name="Zied Belhocine" userId="200cc0e2b299676e" providerId="LiveId" clId="{9D5C2755-5B7D-406A-B8B3-AE8FBAA81AB3}" dt="2026-01-09T08:19:01.683" v="750" actId="1076"/>
+      <pc:sldChg chg="modSp mod ord modNotesTx">
+        <pc:chgData name="Zied Belhocine" userId="200cc0e2b299676e" providerId="LiveId" clId="{9D5C2755-5B7D-406A-B8B3-AE8FBAA81AB3}" dt="2026-01-15T12:41:22.035" v="1137"/>
         <pc:sldMkLst>
           <pc:docMk/>
           <pc:sldMk cId="3063745067" sldId="304"/>
@@ -221,8 +222,8 @@
           </ac:picMkLst>
         </pc:picChg>
       </pc:sldChg>
-      <pc:sldChg chg="modSp mod ord modNotesTx">
-        <pc:chgData name="Zied Belhocine" userId="200cc0e2b299676e" providerId="LiveId" clId="{9D5C2755-5B7D-406A-B8B3-AE8FBAA81AB3}" dt="2026-01-09T15:46:28.044" v="758"/>
+      <pc:sldChg chg="modSp mod ord modShow modNotesTx">
+        <pc:chgData name="Zied Belhocine" userId="200cc0e2b299676e" providerId="LiveId" clId="{9D5C2755-5B7D-406A-B8B3-AE8FBAA81AB3}" dt="2026-01-15T12:41:01.724" v="1135" actId="729"/>
         <pc:sldMkLst>
           <pc:docMk/>
           <pc:sldMk cId="3998171594" sldId="305"/>
@@ -314,6 +315,21 @@
           </ac:picMkLst>
         </pc:picChg>
       </pc:sldChg>
+      <pc:sldChg chg="addSp modSp add mod ord">
+        <pc:chgData name="Zied Belhocine" userId="200cc0e2b299676e" providerId="LiveId" clId="{9D5C2755-5B7D-406A-B8B3-AE8FBAA81AB3}" dt="2026-01-15T12:37:52.003" v="1132" actId="962"/>
+        <pc:sldMkLst>
+          <pc:docMk/>
+          <pc:sldMk cId="392528271" sldId="309"/>
+        </pc:sldMkLst>
+        <pc:picChg chg="add mod">
+          <ac:chgData name="Zied Belhocine" userId="200cc0e2b299676e" providerId="LiveId" clId="{9D5C2755-5B7D-406A-B8B3-AE8FBAA81AB3}" dt="2026-01-15T12:37:52.003" v="1132" actId="962"/>
+          <ac:picMkLst>
+            <pc:docMk/>
+            <pc:sldMk cId="392528271" sldId="309"/>
+            <ac:picMk id="3" creationId="{1644FE99-D60F-F9B7-54F1-E7C63F4B7639}"/>
+          </ac:picMkLst>
+        </pc:picChg>
+      </pc:sldChg>
       <pc:sldChg chg="new del">
         <pc:chgData name="Zied Belhocine" userId="200cc0e2b299676e" providerId="LiveId" clId="{9D5C2755-5B7D-406A-B8B3-AE8FBAA81AB3}" dt="2026-01-09T15:51:44.127" v="901" actId="47"/>
         <pc:sldMkLst>
@@ -445,7 +461,7 @@
             <a:pPr rtl="0"/>
             <a:fld id="{996F3730-8562-4D7F-A2D1-B258C4FC42CB}" type="datetime1">
               <a:rPr lang="fr-FR" smtClean="0"/>
-              <a:t>09/01/2026</a:t>
+              <a:t>15/01/2026</a:t>
             </a:fld>
             <a:endParaRPr lang="fr-FR"/>
           </a:p>
@@ -627,7 +643,7 @@
             <a:fld id="{0F28B237-C4D2-43EE-AC18-AA163EB3D7BC}" type="datetime1">
               <a:rPr lang="fr-FR" smtClean="0"/>
               <a:pPr/>
-              <a:t>09/01/2026</a:t>
+              <a:t>15/01/2026</a:t>
             </a:fld>
             <a:endParaRPr lang="fr-FR" dirty="0"/>
           </a:p>
@@ -1081,7 +1097,7 @@
     </p:spTree>
     <p:extLst>
       <p:ext uri="{BB962C8B-B14F-4D97-AF65-F5344CB8AC3E}">
-        <p14:creationId xmlns:p14="http://schemas.microsoft.com/office/powerpoint/2010/main" val="4139433125"/>
+        <p14:creationId xmlns:p14="http://schemas.microsoft.com/office/powerpoint/2010/main" val="526867562"/>
       </p:ext>
     </p:extLst>
   </p:cSld>
@@ -1154,7 +1170,7 @@
             </a:pPr>
             <a:r>
               <a:rPr lang="fr-FR" dirty="0"/>
-              <a:t>Cela a eu un impact fort sur le taux de conversion qui est divisé par deux entre juillet et février (0,10 à 0,05). Néanmoins, il y a une tendance de stabilisation sur les deux derniers mois et décroit moins rapidement que le taux de conversion augmente, c’est bon signe.</a:t>
+              <a:t>La conséquence de cela a été une forte augmentation du nombre de visites et de ventes dès cette transition (juillet 2019). Le nombre de visite augmente d’ailleurs de manière exponentielle (presque +150k entre janvier et février ~ +30% ).</a:t>
             </a:r>
           </a:p>
           <a:p>
@@ -1189,7 +1205,7 @@
     </p:spTree>
     <p:extLst>
       <p:ext uri="{BB962C8B-B14F-4D97-AF65-F5344CB8AC3E}">
-        <p14:creationId xmlns:p14="http://schemas.microsoft.com/office/powerpoint/2010/main" val="2640048239"/>
+        <p14:creationId xmlns:p14="http://schemas.microsoft.com/office/powerpoint/2010/main" val="1408687645"/>
       </p:ext>
     </p:extLst>
   </p:cSld>
@@ -1262,8 +1278,11 @@
             </a:pPr>
             <a:r>
               <a:rPr lang="fr-FR" dirty="0"/>
-              <a:t>On peut voir ici que plus ils passent de temps sur notre site, plus ils vont avoir un panier élevé. </a:t>
-            </a:r>
+              <a:t>Cela a eu un impact fort sur le taux de conversion qui est divisé par deux entre juillet et février (0,10 à 0,05). Néanmoins, il y a une tendance de stabilisation sur les deux derniers mois et décroit moins rapidement que le taux de conversion augmente, c’est bon signe.</a:t>
+            </a:r>
+          </a:p>
+          <a:p>
+            <a:endParaRPr lang="fr-FR" dirty="0"/>
           </a:p>
         </p:txBody>
       </p:sp>
@@ -1294,7 +1313,7 @@
     </p:spTree>
     <p:extLst>
       <p:ext uri="{BB962C8B-B14F-4D97-AF65-F5344CB8AC3E}">
-        <p14:creationId xmlns:p14="http://schemas.microsoft.com/office/powerpoint/2010/main" val="292140105"/>
+        <p14:creationId xmlns:p14="http://schemas.microsoft.com/office/powerpoint/2010/main" val="2640048239"/>
       </p:ext>
     </p:extLst>
   </p:cSld>
@@ -1367,11 +1386,8 @@
             </a:pPr>
             <a:r>
               <a:rPr lang="fr-FR" dirty="0"/>
-              <a:t>On constate par ailleurs que ce changement de stratégie entraine des changements de comportements chez nos clients. Ceux-ci ont des profils beaucoup plus variés. Ils sont notamment beaucoup plus nombreux à passer moins de 6 minutes pour faire leurs achats. </a:t>
-            </a:r>
-          </a:p>
-          <a:p>
-            <a:endParaRPr lang="fr-FR" dirty="0"/>
+              <a:t>On peut voir ici que plus ils passent de temps sur notre site, plus ils vont avoir un panier élevé. </a:t>
+            </a:r>
           </a:p>
         </p:txBody>
       </p:sp>
@@ -1402,7 +1418,7 @@
     </p:spTree>
     <p:extLst>
       <p:ext uri="{BB962C8B-B14F-4D97-AF65-F5344CB8AC3E}">
-        <p14:creationId xmlns:p14="http://schemas.microsoft.com/office/powerpoint/2010/main" val="1039879247"/>
+        <p14:creationId xmlns:p14="http://schemas.microsoft.com/office/powerpoint/2010/main" val="292140105"/>
       </p:ext>
     </p:extLst>
   </p:cSld>
@@ -1475,7 +1491,7 @@
             </a:pPr>
             <a:r>
               <a:rPr lang="fr-FR" dirty="0"/>
-              <a:t>La conséquence de cela a été une forte augmentation du nombre de visites et de ventes dès cette transition (juillet 2019). Le nombre de visite augmente d’ailleurs de manière exponentielle (presque +150k entre janvier et février ~ +30% ).</a:t>
+              <a:t>On constate par ailleurs que ce changement de stratégie entraine des changements de comportements chez nos clients. Ceux-ci ont des profils beaucoup plus variés. Ils sont notamment beaucoup plus nombreux à passer moins de 6 minutes pour faire leurs achats. </a:t>
             </a:r>
           </a:p>
           <a:p>
@@ -1510,7 +1526,7 @@
     </p:spTree>
     <p:extLst>
       <p:ext uri="{BB962C8B-B14F-4D97-AF65-F5344CB8AC3E}">
-        <p14:creationId xmlns:p14="http://schemas.microsoft.com/office/powerpoint/2010/main" val="1408687645"/>
+        <p14:creationId xmlns:p14="http://schemas.microsoft.com/office/powerpoint/2010/main" val="1039879247"/>
       </p:ext>
     </p:extLst>
   </p:cSld>
@@ -1539,7 +1555,7 @@
       </p:grpSpPr>
       <p:sp>
         <p:nvSpPr>
-          <p:cNvPr id="2" name="Espace réservé de l’image des diapositives 1"/>
+          <p:cNvPr id="2" name="Espace réservé de l'image des diapositives 1"/>
           <p:cNvSpPr>
             <a:spLocks noGrp="1" noRot="1" noChangeAspect="1"/>
           </p:cNvSpPr>
@@ -1551,7 +1567,7 @@
       </p:sp>
       <p:sp>
         <p:nvSpPr>
-          <p:cNvPr id="3" name="Espace réservé des commentaires 2"/>
+          <p:cNvPr id="3" name="Espace réservé des notes 2"/>
           <p:cNvSpPr>
             <a:spLocks noGrp="1"/>
           </p:cNvSpPr>
@@ -1561,11 +1577,33 @@
         </p:nvSpPr>
         <p:spPr/>
         <p:txBody>
-          <a:bodyPr rtlCol="0"/>
+          <a:bodyPr/>
           <a:lstStyle/>
           <a:p>
-            <a:pPr rtl="0"/>
-            <a:endParaRPr lang="fr-FR"/>
+            <a:pPr marL="0" marR="0" lvl="0" indent="0" algn="l" defTabSz="914400" rtl="0" eaLnBrk="1" fontAlgn="auto" latinLnBrk="0" hangingPunct="1">
+              <a:lnSpc>
+                <a:spcPct val="100000"/>
+              </a:lnSpc>
+              <a:spcBef>
+                <a:spcPts val="0"/>
+              </a:spcBef>
+              <a:spcAft>
+                <a:spcPts val="0"/>
+              </a:spcAft>
+              <a:buClrTx/>
+              <a:buSzTx/>
+              <a:buFontTx/>
+              <a:buNone/>
+              <a:tabLst/>
+              <a:defRPr/>
+            </a:pPr>
+            <a:r>
+              <a:rPr lang="fr-FR" sz="1000" dirty="0"/>
+              <a:t>L’année dernière, nous avons tourné la page du High Tech pour concentrer nos efforts sur la nourriture et les biens de consommation (juillet 2019). Cet arrêt du high tech a mécaniquement fait baisser notre chiffre total. Cependant l’évolution de la partie nourriture est très encourageante.</a:t>
+            </a:r>
+          </a:p>
+          <a:p>
+            <a:endParaRPr lang="fr-FR" dirty="0"/>
           </a:p>
         </p:txBody>
       </p:sp>
@@ -1581,13 +1619,99 @@
         </p:nvSpPr>
         <p:spPr/>
         <p:txBody>
-          <a:bodyPr rtlCol="0"/>
+          <a:bodyPr/>
           <a:lstStyle/>
           <a:p>
             <a:pPr rtl="0"/>
             <a:fld id="{D4B9A9E5-4F7F-4A7D-9DE1-899232329269}" type="slidenum">
               <a:rPr lang="fr-FR" smtClean="0"/>
               <a:t>7</a:t>
+            </a:fld>
+            <a:endParaRPr lang="fr-FR"/>
+          </a:p>
+        </p:txBody>
+      </p:sp>
+    </p:spTree>
+    <p:extLst>
+      <p:ext uri="{BB962C8B-B14F-4D97-AF65-F5344CB8AC3E}">
+        <p14:creationId xmlns:p14="http://schemas.microsoft.com/office/powerpoint/2010/main" val="4139433125"/>
+      </p:ext>
+    </p:extLst>
+  </p:cSld>
+  <p:clrMapOvr>
+    <a:masterClrMapping/>
+  </p:clrMapOvr>
+</p:notes>
+</file>
+
+<file path=ppt/notesSlides/notesSlide8.xml><?xml version="1.0" encoding="utf-8"?>
+<p:notes xmlns:a="http://schemas.openxmlformats.org/drawingml/2006/main" xmlns:r="http://schemas.openxmlformats.org/officeDocument/2006/relationships" xmlns:p="http://schemas.openxmlformats.org/presentationml/2006/main">
+  <p:cSld>
+    <p:spTree>
+      <p:nvGrpSpPr>
+        <p:cNvPr id="1" name=""/>
+        <p:cNvGrpSpPr/>
+        <p:nvPr/>
+      </p:nvGrpSpPr>
+      <p:grpSpPr>
+        <a:xfrm>
+          <a:off x="0" y="0"/>
+          <a:ext cx="0" cy="0"/>
+          <a:chOff x="0" y="0"/>
+          <a:chExt cx="0" cy="0"/>
+        </a:xfrm>
+      </p:grpSpPr>
+      <p:sp>
+        <p:nvSpPr>
+          <p:cNvPr id="2" name="Espace réservé de l’image des diapositives 1"/>
+          <p:cNvSpPr>
+            <a:spLocks noGrp="1" noRot="1" noChangeAspect="1"/>
+          </p:cNvSpPr>
+          <p:nvPr>
+            <p:ph type="sldImg"/>
+          </p:nvPr>
+        </p:nvSpPr>
+        <p:spPr/>
+      </p:sp>
+      <p:sp>
+        <p:nvSpPr>
+          <p:cNvPr id="3" name="Espace réservé des commentaires 2"/>
+          <p:cNvSpPr>
+            <a:spLocks noGrp="1"/>
+          </p:cNvSpPr>
+          <p:nvPr>
+            <p:ph type="body" idx="1"/>
+          </p:nvPr>
+        </p:nvSpPr>
+        <p:spPr/>
+        <p:txBody>
+          <a:bodyPr rtlCol="0"/>
+          <a:lstStyle/>
+          <a:p>
+            <a:pPr rtl="0"/>
+            <a:endParaRPr lang="fr-FR"/>
+          </a:p>
+        </p:txBody>
+      </p:sp>
+      <p:sp>
+        <p:nvSpPr>
+          <p:cNvPr id="4" name="Espace réservé du numéro de diapositive 3"/>
+          <p:cNvSpPr>
+            <a:spLocks noGrp="1"/>
+          </p:cNvSpPr>
+          <p:nvPr>
+            <p:ph type="sldNum" sz="quarter" idx="5"/>
+          </p:nvPr>
+        </p:nvSpPr>
+        <p:spPr/>
+        <p:txBody>
+          <a:bodyPr rtlCol="0"/>
+          <a:lstStyle/>
+          <a:p>
+            <a:pPr rtl="0"/>
+            <a:fld id="{D4B9A9E5-4F7F-4A7D-9DE1-899232329269}" type="slidenum">
+              <a:rPr lang="fr-FR" smtClean="0"/>
+              <a:t>8</a:t>
             </a:fld>
             <a:endParaRPr lang="fr-FR"/>
           </a:p>
@@ -17237,10 +17361,40 @@
           </a:prstGeom>
         </p:spPr>
       </p:pic>
+      <p:pic>
+        <p:nvPicPr>
+          <p:cNvPr id="3" name="Image 2" descr="Une image contenant texte, capture d’écran, ligne, Tracé&#10;&#10;Le contenu généré par l’IA peut être incorrect.">
+            <a:extLst>
+              <a:ext uri="{FF2B5EF4-FFF2-40B4-BE49-F238E27FC236}">
+                <a16:creationId xmlns:a16="http://schemas.microsoft.com/office/drawing/2014/main" id="{1644FE99-D60F-F9B7-54F1-E7C63F4B7639}"/>
+              </a:ext>
+            </a:extLst>
+          </p:cNvPr>
+          <p:cNvPicPr>
+            <a:picLocks noChangeAspect="1"/>
+          </p:cNvPicPr>
+          <p:nvPr/>
+        </p:nvPicPr>
+        <p:blipFill>
+          <a:blip r:embed="rId5"/>
+          <a:stretch>
+            <a:fillRect/>
+          </a:stretch>
+        </p:blipFill>
+        <p:spPr>
+          <a:xfrm>
+            <a:off x="1980262" y="227870"/>
+            <a:ext cx="8231475" cy="6402259"/>
+          </a:xfrm>
+          <a:prstGeom prst="rect">
+            <a:avLst/>
+          </a:prstGeom>
+        </p:spPr>
+      </p:pic>
     </p:spTree>
     <p:extLst>
       <p:ext uri="{BB962C8B-B14F-4D97-AF65-F5344CB8AC3E}">
-        <p14:creationId xmlns:p14="http://schemas.microsoft.com/office/powerpoint/2010/main" val="4153042215"/>
+        <p14:creationId xmlns:p14="http://schemas.microsoft.com/office/powerpoint/2010/main" val="392528271"/>
       </p:ext>
     </p:extLst>
   </p:cSld>
@@ -17305,10 +17459,10 @@
       </p:sp>
       <p:pic>
         <p:nvPicPr>
-          <p:cNvPr id="3" name="Image 2">
-            <a:extLst>
-              <a:ext uri="{FF2B5EF4-FFF2-40B4-BE49-F238E27FC236}">
-                <a16:creationId xmlns:a16="http://schemas.microsoft.com/office/drawing/2014/main" id="{E91176A3-5CA2-CCD2-8A6A-6351999522B5}"/>
+          <p:cNvPr id="2" name="Image 1">
+            <a:extLst>
+              <a:ext uri="{FF2B5EF4-FFF2-40B4-BE49-F238E27FC236}">
+                <a16:creationId xmlns:a16="http://schemas.microsoft.com/office/drawing/2014/main" id="{2415FE7D-904B-B539-B403-F92F79825ED8}"/>
               </a:ext>
             </a:extLst>
           </p:cNvPr>
@@ -17325,8 +17479,8 @@
         </p:blipFill>
         <p:spPr>
           <a:xfrm>
-            <a:off x="2101057" y="462373"/>
-            <a:ext cx="7989885" cy="5998968"/>
+            <a:off x="1452294" y="468058"/>
+            <a:ext cx="9287412" cy="5921884"/>
           </a:xfrm>
           <a:prstGeom prst="rect">
             <a:avLst/>
@@ -17335,10 +17489,10 @@
       </p:pic>
       <p:sp>
         <p:nvSpPr>
-          <p:cNvPr id="5" name="ZoneTexte 4">
-            <a:extLst>
-              <a:ext uri="{FF2B5EF4-FFF2-40B4-BE49-F238E27FC236}">
-                <a16:creationId xmlns:a16="http://schemas.microsoft.com/office/drawing/2014/main" id="{5F2CDB22-66E5-2C01-0C7C-51F41FB5CFD6}"/>
+          <p:cNvPr id="3" name="ZoneTexte 2">
+            <a:extLst>
+              <a:ext uri="{FF2B5EF4-FFF2-40B4-BE49-F238E27FC236}">
+                <a16:creationId xmlns:a16="http://schemas.microsoft.com/office/drawing/2014/main" id="{E503D5C8-EABC-8DB3-766D-2D8D43C29F2E}"/>
               </a:ext>
             </a:extLst>
           </p:cNvPr>
@@ -17347,8 +17501,8 @@
         </p:nvSpPr>
         <p:spPr>
           <a:xfrm>
-            <a:off x="2357728" y="6123543"/>
-            <a:ext cx="8289967" cy="369332"/>
+            <a:off x="974683" y="6020610"/>
+            <a:ext cx="10515600" cy="369332"/>
           </a:xfrm>
           <a:prstGeom prst="rect">
             <a:avLst/>
@@ -17361,20 +17515,20 @@
           </a:bodyPr>
           <a:lstStyle/>
           <a:p>
-            <a:pPr algn="just"/>
+            <a:pPr algn="ctr"/>
             <a:r>
               <a:rPr lang="fr-FR" dirty="0"/>
-              <a:t>Taux de conversion qui est divisé par deux entre juillet et février (0,10 à 0,05). </a:t>
-            </a:r>
-          </a:p>
-        </p:txBody>
-      </p:sp>
-      <p:sp>
-        <p:nvSpPr>
-          <p:cNvPr id="6" name="Titre 1">
-            <a:extLst>
-              <a:ext uri="{FF2B5EF4-FFF2-40B4-BE49-F238E27FC236}">
-                <a16:creationId xmlns:a16="http://schemas.microsoft.com/office/drawing/2014/main" id="{82AF1DA3-8DEB-180C-05DF-BBE028A18A6E}"/>
+              <a:t>Forte augmentation du nombre de visites et de ventes dès cette transition (juillet 2019). </a:t>
+            </a:r>
+          </a:p>
+        </p:txBody>
+      </p:sp>
+      <p:sp>
+        <p:nvSpPr>
+          <p:cNvPr id="5" name="Titre 1">
+            <a:extLst>
+              <a:ext uri="{FF2B5EF4-FFF2-40B4-BE49-F238E27FC236}">
+                <a16:creationId xmlns:a16="http://schemas.microsoft.com/office/drawing/2014/main" id="{4F487A6A-202B-34F2-3157-3A0DB7CFF017}"/>
               </a:ext>
             </a:extLst>
           </p:cNvPr>
@@ -17387,27 +17541,29 @@
         </p:nvSpPr>
         <p:spPr>
           <a:xfrm>
-            <a:off x="688848" y="72736"/>
-            <a:ext cx="10515600" cy="942543"/>
-          </a:xfrm>
-        </p:spPr>
-        <p:txBody>
-          <a:bodyPr/>
+            <a:off x="842211" y="6393"/>
+            <a:ext cx="10515600" cy="923330"/>
+          </a:xfrm>
+        </p:spPr>
+        <p:txBody>
+          <a:bodyPr>
+            <a:normAutofit/>
+          </a:bodyPr>
           <a:lstStyle/>
           <a:p>
             <a:r>
               <a:rPr lang="fr-FR" dirty="0"/>
-              <a:t>Évolution du taux de conversion au cours des 12 derniers mois</a:t>
+              <a:t>Évolution du nombre de ventes et de visites sur le site au cours des 12 derniers mois</a:t>
             </a:r>
           </a:p>
         </p:txBody>
       </p:sp>
       <p:pic>
         <p:nvPicPr>
-          <p:cNvPr id="7" name="Image 6" descr="Une image contenant texte, Police, capture d’écran, logo&#10;&#10;Le contenu généré par l’IA peut être incorrect.">
-            <a:extLst>
-              <a:ext uri="{FF2B5EF4-FFF2-40B4-BE49-F238E27FC236}">
-                <a16:creationId xmlns:a16="http://schemas.microsoft.com/office/drawing/2014/main" id="{9439E07F-D4F2-2CBD-3578-0B61A7D1B602}"/>
+          <p:cNvPr id="6" name="Image 5" descr="Une image contenant texte, Police, capture d’écran, logo&#10;&#10;Le contenu généré par l’IA peut être incorrect.">
+            <a:extLst>
+              <a:ext uri="{FF2B5EF4-FFF2-40B4-BE49-F238E27FC236}">
+                <a16:creationId xmlns:a16="http://schemas.microsoft.com/office/drawing/2014/main" id="{0512DA33-A46C-9CBD-2F91-B8108D6CF218}"/>
               </a:ext>
             </a:extLst>
           </p:cNvPr>
@@ -17435,7 +17591,7 @@
     </p:spTree>
     <p:extLst>
       <p:ext uri="{BB962C8B-B14F-4D97-AF65-F5344CB8AC3E}">
-        <p14:creationId xmlns:p14="http://schemas.microsoft.com/office/powerpoint/2010/main" val="3998171594"/>
+        <p14:creationId xmlns:p14="http://schemas.microsoft.com/office/powerpoint/2010/main" val="3063745067"/>
       </p:ext>
     </p:extLst>
   </p:cSld>
@@ -17446,7 +17602,7 @@
 </file>
 
 <file path=ppt/slides/slide4.xml><?xml version="1.0" encoding="utf-8"?>
-<p:sld xmlns:a="http://schemas.openxmlformats.org/drawingml/2006/main" xmlns:r="http://schemas.openxmlformats.org/officeDocument/2006/relationships" xmlns:p="http://schemas.openxmlformats.org/presentationml/2006/main">
+<p:sld xmlns:a="http://schemas.openxmlformats.org/drawingml/2006/main" xmlns:r="http://schemas.openxmlformats.org/officeDocument/2006/relationships" xmlns:p="http://schemas.openxmlformats.org/presentationml/2006/main" show="0">
   <p:cSld>
     <p:spTree>
       <p:nvGrpSpPr>
@@ -17500,10 +17656,10 @@
       </p:sp>
       <p:pic>
         <p:nvPicPr>
-          <p:cNvPr id="5" name="Image 4" descr="Une image contenant capture d’écran, visualisation&#10;&#10;Le contenu généré par l’IA peut être incorrect.">
-            <a:extLst>
-              <a:ext uri="{FF2B5EF4-FFF2-40B4-BE49-F238E27FC236}">
-                <a16:creationId xmlns:a16="http://schemas.microsoft.com/office/drawing/2014/main" id="{29786476-4BDF-EE96-67CE-9A1137BB4B39}"/>
+          <p:cNvPr id="3" name="Image 2">
+            <a:extLst>
+              <a:ext uri="{FF2B5EF4-FFF2-40B4-BE49-F238E27FC236}">
+                <a16:creationId xmlns:a16="http://schemas.microsoft.com/office/drawing/2014/main" id="{E91176A3-5CA2-CCD2-8A6A-6351999522B5}"/>
               </a:ext>
             </a:extLst>
           </p:cNvPr>
@@ -17520,8 +17676,8 @@
         </p:blipFill>
         <p:spPr>
           <a:xfrm>
-            <a:off x="2125160" y="464179"/>
-            <a:ext cx="7751180" cy="5863885"/>
+            <a:off x="2101057" y="462373"/>
+            <a:ext cx="7989885" cy="5998968"/>
           </a:xfrm>
           <a:prstGeom prst="rect">
             <a:avLst/>
@@ -17530,10 +17686,10 @@
       </p:pic>
       <p:sp>
         <p:nvSpPr>
-          <p:cNvPr id="6" name="ZoneTexte 5">
-            <a:extLst>
-              <a:ext uri="{FF2B5EF4-FFF2-40B4-BE49-F238E27FC236}">
-                <a16:creationId xmlns:a16="http://schemas.microsoft.com/office/drawing/2014/main" id="{672B12A8-6C11-5AE7-B843-F4233C2A8988}"/>
+          <p:cNvPr id="5" name="ZoneTexte 4">
+            <a:extLst>
+              <a:ext uri="{FF2B5EF4-FFF2-40B4-BE49-F238E27FC236}">
+                <a16:creationId xmlns:a16="http://schemas.microsoft.com/office/drawing/2014/main" id="{5F2CDB22-66E5-2C01-0C7C-51F41FB5CFD6}"/>
               </a:ext>
             </a:extLst>
           </p:cNvPr>
@@ -17542,8 +17698,8 @@
         </p:nvSpPr>
         <p:spPr>
           <a:xfrm>
-            <a:off x="2315660" y="6106886"/>
-            <a:ext cx="7560680" cy="646331"/>
+            <a:off x="2357728" y="6123543"/>
+            <a:ext cx="8289967" cy="369332"/>
           </a:xfrm>
           <a:prstGeom prst="rect">
             <a:avLst/>
@@ -17556,27 +17712,20 @@
           </a:bodyPr>
           <a:lstStyle/>
           <a:p>
-            <a:pPr algn="ctr"/>
+            <a:pPr algn="just"/>
             <a:r>
               <a:rPr lang="fr-FR" dirty="0"/>
-              <a:t>Forte concentration de paniers autour de 40€. </a:t>
-            </a:r>
-          </a:p>
-          <a:p>
-            <a:pPr algn="ctr"/>
-            <a:r>
-              <a:rPr lang="fr-FR" dirty="0"/>
-              <a:t>Plus ils passent de temps sur notre site, plus ils vont avoir un panier élevé. </a:t>
-            </a:r>
-          </a:p>
-        </p:txBody>
-      </p:sp>
-      <p:sp>
-        <p:nvSpPr>
-          <p:cNvPr id="7" name="Titre 1">
-            <a:extLst>
-              <a:ext uri="{FF2B5EF4-FFF2-40B4-BE49-F238E27FC236}">
-                <a16:creationId xmlns:a16="http://schemas.microsoft.com/office/drawing/2014/main" id="{9B346097-CD60-B70F-E35D-83B3B4CC3325}"/>
+              <a:t>Taux de conversion qui est divisé par deux entre juillet et février (0,10 à 0,05). </a:t>
+            </a:r>
+          </a:p>
+        </p:txBody>
+      </p:sp>
+      <p:sp>
+        <p:nvSpPr>
+          <p:cNvPr id="6" name="Titre 1">
+            <a:extLst>
+              <a:ext uri="{FF2B5EF4-FFF2-40B4-BE49-F238E27FC236}">
+                <a16:creationId xmlns:a16="http://schemas.microsoft.com/office/drawing/2014/main" id="{82AF1DA3-8DEB-180C-05DF-BBE028A18A6E}"/>
               </a:ext>
             </a:extLst>
           </p:cNvPr>
@@ -17589,8 +17738,8 @@
         </p:nvSpPr>
         <p:spPr>
           <a:xfrm>
-            <a:off x="842211" y="228699"/>
-            <a:ext cx="10515600" cy="911271"/>
+            <a:off x="688848" y="72736"/>
+            <a:ext cx="10515600" cy="942543"/>
           </a:xfrm>
         </p:spPr>
         <p:txBody>
@@ -17599,17 +17748,17 @@
           <a:p>
             <a:r>
               <a:rPr lang="fr-FR" dirty="0"/>
-              <a:t>Comparaison entre le temps passé sur le site et le panier moyen</a:t>
+              <a:t>Évolution du taux de conversion au cours des 12 derniers mois</a:t>
             </a:r>
           </a:p>
         </p:txBody>
       </p:sp>
       <p:pic>
         <p:nvPicPr>
-          <p:cNvPr id="8" name="Image 7" descr="Une image contenant texte, Police, capture d’écran, logo&#10;&#10;Le contenu généré par l’IA peut être incorrect.">
-            <a:extLst>
-              <a:ext uri="{FF2B5EF4-FFF2-40B4-BE49-F238E27FC236}">
-                <a16:creationId xmlns:a16="http://schemas.microsoft.com/office/drawing/2014/main" id="{A4C1BADD-9F05-A50E-1952-FF83019CB9ED}"/>
+          <p:cNvPr id="7" name="Image 6" descr="Une image contenant texte, Police, capture d’écran, logo&#10;&#10;Le contenu généré par l’IA peut être incorrect.">
+            <a:extLst>
+              <a:ext uri="{FF2B5EF4-FFF2-40B4-BE49-F238E27FC236}">
+                <a16:creationId xmlns:a16="http://schemas.microsoft.com/office/drawing/2014/main" id="{9439E07F-D4F2-2CBD-3578-0B61A7D1B602}"/>
               </a:ext>
             </a:extLst>
           </p:cNvPr>
@@ -17637,7 +17786,7 @@
     </p:spTree>
     <p:extLst>
       <p:ext uri="{BB962C8B-B14F-4D97-AF65-F5344CB8AC3E}">
-        <p14:creationId xmlns:p14="http://schemas.microsoft.com/office/powerpoint/2010/main" val="1250150470"/>
+        <p14:creationId xmlns:p14="http://schemas.microsoft.com/office/powerpoint/2010/main" val="3998171594"/>
       </p:ext>
     </p:extLst>
   </p:cSld>
@@ -17702,10 +17851,10 @@
       </p:sp>
       <p:pic>
         <p:nvPicPr>
-          <p:cNvPr id="2" name="Image 1" descr="Une image contenant texte, diagramme, capture d’écran, Rectangle&#10;&#10;Le contenu généré par l’IA peut être incorrect.">
-            <a:extLst>
-              <a:ext uri="{FF2B5EF4-FFF2-40B4-BE49-F238E27FC236}">
-                <a16:creationId xmlns:a16="http://schemas.microsoft.com/office/drawing/2014/main" id="{2CFC9D1A-A636-6112-F50A-51C38D5FEE45}"/>
+          <p:cNvPr id="5" name="Image 4" descr="Une image contenant capture d’écran, visualisation&#10;&#10;Le contenu généré par l’IA peut être incorrect.">
+            <a:extLst>
+              <a:ext uri="{FF2B5EF4-FFF2-40B4-BE49-F238E27FC236}">
+                <a16:creationId xmlns:a16="http://schemas.microsoft.com/office/drawing/2014/main" id="{29786476-4BDF-EE96-67CE-9A1137BB4B39}"/>
               </a:ext>
             </a:extLst>
           </p:cNvPr>
@@ -17722,8 +17871,8 @@
         </p:blipFill>
         <p:spPr>
           <a:xfrm>
-            <a:off x="2171237" y="498763"/>
-            <a:ext cx="7796230" cy="5486401"/>
+            <a:off x="2125160" y="464179"/>
+            <a:ext cx="7751180" cy="5863885"/>
           </a:xfrm>
           <a:prstGeom prst="rect">
             <a:avLst/>
@@ -17732,10 +17881,10 @@
       </p:pic>
       <p:sp>
         <p:nvSpPr>
-          <p:cNvPr id="3" name="ZoneTexte 2">
-            <a:extLst>
-              <a:ext uri="{FF2B5EF4-FFF2-40B4-BE49-F238E27FC236}">
-                <a16:creationId xmlns:a16="http://schemas.microsoft.com/office/drawing/2014/main" id="{EF0CD643-2533-5CD6-2446-CB3E7AD4785B}"/>
+          <p:cNvPr id="6" name="ZoneTexte 5">
+            <a:extLst>
+              <a:ext uri="{FF2B5EF4-FFF2-40B4-BE49-F238E27FC236}">
+                <a16:creationId xmlns:a16="http://schemas.microsoft.com/office/drawing/2014/main" id="{672B12A8-6C11-5AE7-B843-F4233C2A8988}"/>
               </a:ext>
             </a:extLst>
           </p:cNvPr>
@@ -17744,8 +17893,8 @@
         </p:nvSpPr>
         <p:spPr>
           <a:xfrm>
-            <a:off x="1242352" y="5541453"/>
-            <a:ext cx="9346563" cy="1200329"/>
+            <a:off x="2315660" y="6106886"/>
+            <a:ext cx="7560680" cy="646331"/>
           </a:xfrm>
           <a:prstGeom prst="rect">
             <a:avLst/>
@@ -17761,28 +17910,24 @@
             <a:pPr algn="ctr"/>
             <a:r>
               <a:rPr lang="fr-FR" dirty="0"/>
-              <a:t>Variance augmente et les clients sont beaucoup plus nombreux à passer moins de 6 minutes pour faire leurs achats.</a:t>
+              <a:t>Forte concentration de paniers autour de 40€. </a:t>
             </a:r>
           </a:p>
           <a:p>
             <a:pPr algn="ctr"/>
-            <a:endParaRPr lang="fr-FR" dirty="0"/>
-          </a:p>
-          <a:p>
-            <a:pPr algn="ctr"/>
             <a:r>
               <a:rPr lang="fr-FR" dirty="0"/>
-              <a:t>Revoir la segmentation de notre base client est une priorité.</a:t>
-            </a:r>
-          </a:p>
-        </p:txBody>
-      </p:sp>
-      <p:sp>
-        <p:nvSpPr>
-          <p:cNvPr id="5" name="Titre 1">
-            <a:extLst>
-              <a:ext uri="{FF2B5EF4-FFF2-40B4-BE49-F238E27FC236}">
-                <a16:creationId xmlns:a16="http://schemas.microsoft.com/office/drawing/2014/main" id="{B638DCEF-0E7B-FF5A-E4B0-9C14906D4760}"/>
+              <a:t>Plus ils passent de temps sur notre site, plus ils vont avoir un panier élevé. </a:t>
+            </a:r>
+          </a:p>
+        </p:txBody>
+      </p:sp>
+      <p:sp>
+        <p:nvSpPr>
+          <p:cNvPr id="7" name="Titre 1">
+            <a:extLst>
+              <a:ext uri="{FF2B5EF4-FFF2-40B4-BE49-F238E27FC236}">
+                <a16:creationId xmlns:a16="http://schemas.microsoft.com/office/drawing/2014/main" id="{9B346097-CD60-B70F-E35D-83B3B4CC3325}"/>
               </a:ext>
             </a:extLst>
           </p:cNvPr>
@@ -17795,8 +17940,8 @@
         </p:nvSpPr>
         <p:spPr>
           <a:xfrm>
-            <a:off x="838200" y="116218"/>
-            <a:ext cx="10515600" cy="880197"/>
+            <a:off x="842211" y="228699"/>
+            <a:ext cx="10515600" cy="911271"/>
           </a:xfrm>
         </p:spPr>
         <p:txBody>
@@ -17805,17 +17950,17 @@
           <a:p>
             <a:r>
               <a:rPr lang="fr-FR" dirty="0"/>
-              <a:t>Évolution de la variabilité du temps passé sur le site au cours des 12 derniers mois</a:t>
+              <a:t>Comparaison entre le temps passé sur le site et le panier moyen</a:t>
             </a:r>
           </a:p>
         </p:txBody>
       </p:sp>
       <p:pic>
         <p:nvPicPr>
-          <p:cNvPr id="6" name="Image 5" descr="Une image contenant texte, Police, capture d’écran, logo&#10;&#10;Le contenu généré par l’IA peut être incorrect.">
-            <a:extLst>
-              <a:ext uri="{FF2B5EF4-FFF2-40B4-BE49-F238E27FC236}">
-                <a16:creationId xmlns:a16="http://schemas.microsoft.com/office/drawing/2014/main" id="{4F138E42-FF66-5DDF-93AB-626C58984D17}"/>
+          <p:cNvPr id="8" name="Image 7" descr="Une image contenant texte, Police, capture d’écran, logo&#10;&#10;Le contenu généré par l’IA peut être incorrect.">
+            <a:extLst>
+              <a:ext uri="{FF2B5EF4-FFF2-40B4-BE49-F238E27FC236}">
+                <a16:creationId xmlns:a16="http://schemas.microsoft.com/office/drawing/2014/main" id="{A4C1BADD-9F05-A50E-1952-FF83019CB9ED}"/>
               </a:ext>
             </a:extLst>
           </p:cNvPr>
@@ -17843,7 +17988,7 @@
     </p:spTree>
     <p:extLst>
       <p:ext uri="{BB962C8B-B14F-4D97-AF65-F5344CB8AC3E}">
-        <p14:creationId xmlns:p14="http://schemas.microsoft.com/office/powerpoint/2010/main" val="2353362535"/>
+        <p14:creationId xmlns:p14="http://schemas.microsoft.com/office/powerpoint/2010/main" val="1250150470"/>
       </p:ext>
     </p:extLst>
   </p:cSld>
@@ -17908,10 +18053,10 @@
       </p:sp>
       <p:pic>
         <p:nvPicPr>
-          <p:cNvPr id="2" name="Image 1">
-            <a:extLst>
-              <a:ext uri="{FF2B5EF4-FFF2-40B4-BE49-F238E27FC236}">
-                <a16:creationId xmlns:a16="http://schemas.microsoft.com/office/drawing/2014/main" id="{2415FE7D-904B-B539-B403-F92F79825ED8}"/>
+          <p:cNvPr id="2" name="Image 1" descr="Une image contenant texte, diagramme, capture d’écran, Rectangle&#10;&#10;Le contenu généré par l’IA peut être incorrect.">
+            <a:extLst>
+              <a:ext uri="{FF2B5EF4-FFF2-40B4-BE49-F238E27FC236}">
+                <a16:creationId xmlns:a16="http://schemas.microsoft.com/office/drawing/2014/main" id="{2CFC9D1A-A636-6112-F50A-51C38D5FEE45}"/>
               </a:ext>
             </a:extLst>
           </p:cNvPr>
@@ -17928,8 +18073,8 @@
         </p:blipFill>
         <p:spPr>
           <a:xfrm>
-            <a:off x="1452294" y="468058"/>
-            <a:ext cx="9287412" cy="5921884"/>
+            <a:off x="2171237" y="498763"/>
+            <a:ext cx="7796230" cy="5486401"/>
           </a:xfrm>
           <a:prstGeom prst="rect">
             <a:avLst/>
@@ -17941,7 +18086,7 @@
           <p:cNvPr id="3" name="ZoneTexte 2">
             <a:extLst>
               <a:ext uri="{FF2B5EF4-FFF2-40B4-BE49-F238E27FC236}">
-                <a16:creationId xmlns:a16="http://schemas.microsoft.com/office/drawing/2014/main" id="{E503D5C8-EABC-8DB3-766D-2D8D43C29F2E}"/>
+                <a16:creationId xmlns:a16="http://schemas.microsoft.com/office/drawing/2014/main" id="{EF0CD643-2533-5CD6-2446-CB3E7AD4785B}"/>
               </a:ext>
             </a:extLst>
           </p:cNvPr>
@@ -17950,8 +18095,8 @@
         </p:nvSpPr>
         <p:spPr>
           <a:xfrm>
-            <a:off x="974683" y="6020610"/>
-            <a:ext cx="10515600" cy="369332"/>
+            <a:off x="1242352" y="5541453"/>
+            <a:ext cx="9346563" cy="1200329"/>
           </a:xfrm>
           <a:prstGeom prst="rect">
             <a:avLst/>
@@ -17967,7 +18112,18 @@
             <a:pPr algn="ctr"/>
             <a:r>
               <a:rPr lang="fr-FR" dirty="0"/>
-              <a:t>Forte augmentation du nombre de visites et de ventes dès cette transition (juillet 2019). </a:t>
+              <a:t>Variance augmente et les clients sont beaucoup plus nombreux à passer moins de 6 minutes pour faire leurs achats.</a:t>
+            </a:r>
+          </a:p>
+          <a:p>
+            <a:pPr algn="ctr"/>
+            <a:endParaRPr lang="fr-FR" dirty="0"/>
+          </a:p>
+          <a:p>
+            <a:pPr algn="ctr"/>
+            <a:r>
+              <a:rPr lang="fr-FR" dirty="0"/>
+              <a:t>Revoir la segmentation de notre base client est une priorité.</a:t>
             </a:r>
           </a:p>
         </p:txBody>
@@ -17977,7 +18133,7 @@
           <p:cNvPr id="5" name="Titre 1">
             <a:extLst>
               <a:ext uri="{FF2B5EF4-FFF2-40B4-BE49-F238E27FC236}">
-                <a16:creationId xmlns:a16="http://schemas.microsoft.com/office/drawing/2014/main" id="{4F487A6A-202B-34F2-3157-3A0DB7CFF017}"/>
+                <a16:creationId xmlns:a16="http://schemas.microsoft.com/office/drawing/2014/main" id="{B638DCEF-0E7B-FF5A-E4B0-9C14906D4760}"/>
               </a:ext>
             </a:extLst>
           </p:cNvPr>
@@ -17990,19 +18146,17 @@
         </p:nvSpPr>
         <p:spPr>
           <a:xfrm>
-            <a:off x="842211" y="6393"/>
-            <a:ext cx="10515600" cy="923330"/>
-          </a:xfrm>
-        </p:spPr>
-        <p:txBody>
-          <a:bodyPr>
-            <a:normAutofit/>
-          </a:bodyPr>
+            <a:off x="838200" y="116218"/>
+            <a:ext cx="10515600" cy="880197"/>
+          </a:xfrm>
+        </p:spPr>
+        <p:txBody>
+          <a:bodyPr/>
           <a:lstStyle/>
           <a:p>
             <a:r>
               <a:rPr lang="fr-FR" dirty="0"/>
-              <a:t>Évolution du nombre de ventes et de visites sur le site au cours des 12 derniers mois</a:t>
+              <a:t>Évolution de la variabilité du temps passé sur le site au cours des 12 derniers mois</a:t>
             </a:r>
           </a:p>
         </p:txBody>
@@ -18012,7 +18166,7 @@
           <p:cNvPr id="6" name="Image 5" descr="Une image contenant texte, Police, capture d’écran, logo&#10;&#10;Le contenu généré par l’IA peut être incorrect.">
             <a:extLst>
               <a:ext uri="{FF2B5EF4-FFF2-40B4-BE49-F238E27FC236}">
-                <a16:creationId xmlns:a16="http://schemas.microsoft.com/office/drawing/2014/main" id="{0512DA33-A46C-9CBD-2F91-B8108D6CF218}"/>
+                <a16:creationId xmlns:a16="http://schemas.microsoft.com/office/drawing/2014/main" id="{4F138E42-FF66-5DDF-93AB-626C58984D17}"/>
               </a:ext>
             </a:extLst>
           </p:cNvPr>
@@ -18040,7 +18194,7 @@
     </p:spTree>
     <p:extLst>
       <p:ext uri="{BB962C8B-B14F-4D97-AF65-F5344CB8AC3E}">
-        <p14:creationId xmlns:p14="http://schemas.microsoft.com/office/powerpoint/2010/main" val="3063745067"/>
+        <p14:creationId xmlns:p14="http://schemas.microsoft.com/office/powerpoint/2010/main" val="2353362535"/>
       </p:ext>
     </p:extLst>
   </p:cSld>
@@ -18069,6 +18223,215 @@
       </p:grpSpPr>
       <p:sp>
         <p:nvSpPr>
+          <p:cNvPr id="4" name="Espace réservé du numéro de diapositive 3">
+            <a:extLst>
+              <a:ext uri="{FF2B5EF4-FFF2-40B4-BE49-F238E27FC236}">
+                <a16:creationId xmlns:a16="http://schemas.microsoft.com/office/drawing/2014/main" id="{328F602C-7F98-4C02-99D4-ED65E00D66A4}"/>
+              </a:ext>
+            </a:extLst>
+          </p:cNvPr>
+          <p:cNvSpPr>
+            <a:spLocks noGrp="1"/>
+          </p:cNvSpPr>
+          <p:nvPr>
+            <p:ph type="sldNum" sz="quarter" idx="12"/>
+          </p:nvPr>
+        </p:nvSpPr>
+        <p:spPr>
+          <a:xfrm>
+            <a:off x="11204448" y="6492875"/>
+            <a:ext cx="987552" cy="365125"/>
+          </a:xfrm>
+        </p:spPr>
+        <p:txBody>
+          <a:bodyPr rtlCol="0"/>
+          <a:lstStyle/>
+          <a:p>
+            <a:pPr rtl="0"/>
+            <a:fld id="{19B51A1E-902D-48AF-9020-955120F399B6}" type="slidenum">
+              <a:rPr lang="fr-FR" smtClean="0"/>
+              <a:pPr rtl="0"/>
+              <a:t>7</a:t>
+            </a:fld>
+            <a:endParaRPr lang="fr-FR" dirty="0"/>
+          </a:p>
+        </p:txBody>
+      </p:sp>
+      <p:pic>
+        <p:nvPicPr>
+          <p:cNvPr id="9" name="Image 8" descr="Une image contenant texte, capture d’écran, ligne, Caractère coloré&#10;&#10;Le contenu généré par l’IA peut être incorrect.">
+            <a:extLst>
+              <a:ext uri="{FF2B5EF4-FFF2-40B4-BE49-F238E27FC236}">
+                <a16:creationId xmlns:a16="http://schemas.microsoft.com/office/drawing/2014/main" id="{F58E550A-D9A8-0666-3A29-58548655973C}"/>
+              </a:ext>
+            </a:extLst>
+          </p:cNvPr>
+          <p:cNvPicPr>
+            <a:picLocks noChangeAspect="1"/>
+          </p:cNvPicPr>
+          <p:nvPr/>
+        </p:nvPicPr>
+        <p:blipFill>
+          <a:blip r:embed="rId3"/>
+          <a:stretch>
+            <a:fillRect/>
+          </a:stretch>
+        </p:blipFill>
+        <p:spPr>
+          <a:xfrm>
+            <a:off x="1801472" y="313235"/>
+            <a:ext cx="8589055" cy="5719236"/>
+          </a:xfrm>
+          <a:prstGeom prst="rect">
+            <a:avLst/>
+          </a:prstGeom>
+        </p:spPr>
+      </p:pic>
+      <p:sp>
+        <p:nvSpPr>
+          <p:cNvPr id="10" name="ZoneTexte 9">
+            <a:extLst>
+              <a:ext uri="{FF2B5EF4-FFF2-40B4-BE49-F238E27FC236}">
+                <a16:creationId xmlns:a16="http://schemas.microsoft.com/office/drawing/2014/main" id="{0519737F-9D2D-31DE-5686-D6F447D5D3F5}"/>
+              </a:ext>
+            </a:extLst>
+          </p:cNvPr>
+          <p:cNvSpPr txBox="1"/>
+          <p:nvPr/>
+        </p:nvSpPr>
+        <p:spPr>
+          <a:xfrm>
+            <a:off x="2136301" y="5621435"/>
+            <a:ext cx="8181109" cy="923330"/>
+          </a:xfrm>
+          <a:prstGeom prst="rect">
+            <a:avLst/>
+          </a:prstGeom>
+          <a:noFill/>
+        </p:spPr>
+        <p:txBody>
+          <a:bodyPr wrap="square" rtlCol="0">
+            <a:spAutoFit/>
+          </a:bodyPr>
+          <a:lstStyle/>
+          <a:p>
+            <a:pPr algn="ctr"/>
+            <a:r>
+              <a:rPr lang="fr-FR" dirty="0"/>
+              <a:t>Arrêt du high tech a mécaniquement fait baisser notre chiffre total. </a:t>
+            </a:r>
+          </a:p>
+          <a:p>
+            <a:pPr algn="ctr"/>
+            <a:r>
+              <a:rPr lang="fr-FR" dirty="0"/>
+              <a:t>Biens de conso. Reste stable ~200k€/mois</a:t>
+            </a:r>
+          </a:p>
+          <a:p>
+            <a:pPr algn="ctr"/>
+            <a:r>
+              <a:rPr lang="fr-FR" dirty="0"/>
+              <a:t>Très forte évolution de la partie nourriture (~+100k entre janvier et février ~+25%)</a:t>
+            </a:r>
+          </a:p>
+        </p:txBody>
+      </p:sp>
+      <p:sp>
+        <p:nvSpPr>
+          <p:cNvPr id="12" name="Titre 1">
+            <a:extLst>
+              <a:ext uri="{FF2B5EF4-FFF2-40B4-BE49-F238E27FC236}">
+                <a16:creationId xmlns:a16="http://schemas.microsoft.com/office/drawing/2014/main" id="{F8A892BB-5431-CA08-0719-4F1CA5524A86}"/>
+              </a:ext>
+            </a:extLst>
+          </p:cNvPr>
+          <p:cNvSpPr>
+            <a:spLocks noGrp="1"/>
+          </p:cNvSpPr>
+          <p:nvPr>
+            <p:ph type="title"/>
+          </p:nvPr>
+        </p:nvSpPr>
+        <p:spPr>
+          <a:xfrm>
+            <a:off x="969056" y="55749"/>
+            <a:ext cx="10515600" cy="923330"/>
+          </a:xfrm>
+        </p:spPr>
+        <p:txBody>
+          <a:bodyPr/>
+          <a:lstStyle/>
+          <a:p>
+            <a:r>
+              <a:rPr lang="fr-FR" dirty="0"/>
+              <a:t>Évolution du chiffre d’affaires au cours des 12 derniers mois par catégorie</a:t>
+            </a:r>
+          </a:p>
+        </p:txBody>
+      </p:sp>
+      <p:pic>
+        <p:nvPicPr>
+          <p:cNvPr id="13" name="Image 12" descr="Une image contenant texte, Police, capture d’écran, logo&#10;&#10;Le contenu généré par l’IA peut être incorrect.">
+            <a:extLst>
+              <a:ext uri="{FF2B5EF4-FFF2-40B4-BE49-F238E27FC236}">
+                <a16:creationId xmlns:a16="http://schemas.microsoft.com/office/drawing/2014/main" id="{12BCD33F-C23C-C272-322D-3BD4DEA0E053}"/>
+              </a:ext>
+            </a:extLst>
+          </p:cNvPr>
+          <p:cNvPicPr>
+            <a:picLocks noChangeAspect="1"/>
+          </p:cNvPicPr>
+          <p:nvPr/>
+        </p:nvPicPr>
+        <p:blipFill>
+          <a:blip r:embed="rId4"/>
+          <a:stretch>
+            <a:fillRect/>
+          </a:stretch>
+        </p:blipFill>
+        <p:spPr>
+          <a:xfrm>
+            <a:off x="10794093" y="6206721"/>
+            <a:ext cx="1127436" cy="422580"/>
+          </a:xfrm>
+          <a:prstGeom prst="rect">
+            <a:avLst/>
+          </a:prstGeom>
+        </p:spPr>
+      </p:pic>
+    </p:spTree>
+    <p:extLst>
+      <p:ext uri="{BB962C8B-B14F-4D97-AF65-F5344CB8AC3E}">
+        <p14:creationId xmlns:p14="http://schemas.microsoft.com/office/powerpoint/2010/main" val="4153042215"/>
+      </p:ext>
+    </p:extLst>
+  </p:cSld>
+  <p:clrMapOvr>
+    <a:masterClrMapping/>
+  </p:clrMapOvr>
+</p:sld>
+</file>
+
+<file path=ppt/slides/slide8.xml><?xml version="1.0" encoding="utf-8"?>
+<p:sld xmlns:a="http://schemas.openxmlformats.org/drawingml/2006/main" xmlns:r="http://schemas.openxmlformats.org/officeDocument/2006/relationships" xmlns:p="http://schemas.openxmlformats.org/presentationml/2006/main">
+  <p:cSld>
+    <p:spTree>
+      <p:nvGrpSpPr>
+        <p:cNvPr id="1" name=""/>
+        <p:cNvGrpSpPr/>
+        <p:nvPr/>
+      </p:nvGrpSpPr>
+      <p:grpSpPr>
+        <a:xfrm>
+          <a:off x="0" y="0"/>
+          <a:ext cx="0" cy="0"/>
+          <a:chOff x="0" y="0"/>
+          <a:chExt cx="0" cy="0"/>
+        </a:xfrm>
+      </p:grpSpPr>
+      <p:sp>
+        <p:nvSpPr>
           <p:cNvPr id="2" name="Titre 1">
             <a:extLst>
               <a:ext uri="{FF2B5EF4-FFF2-40B4-BE49-F238E27FC236}">
@@ -18188,7 +18551,7 @@
             <a:fld id="{B5CEABB6-07DC-46E8-9B57-56EC44A396E5}" type="slidenum">
               <a:rPr lang="fr-FR" smtClean="0"/>
               <a:pPr rtl="0"/>
-              <a:t>7</a:t>
+              <a:t>8</a:t>
             </a:fld>
             <a:endParaRPr lang="fr-FR"/>
           </a:p>
@@ -19029,15 +19392,6 @@
 </file>
 
 <file path=customXml/item1.xml><?xml version="1.0" encoding="utf-8"?>
-<?mso-contentType ?>
-<FormTemplates xmlns="http://schemas.microsoft.com/sharepoint/v3/contenttype/forms">
-  <Display>DocumentLibraryForm</Display>
-  <Edit>DocumentLibraryForm</Edit>
-  <New>DocumentLibraryForm</New>
-</FormTemplates>
-</file>
-
-<file path=customXml/item2.xml><?xml version="1.0" encoding="utf-8"?>
 <ct:contentTypeSchema xmlns:ct="http://schemas.microsoft.com/office/2006/metadata/contentType" xmlns:ma="http://schemas.microsoft.com/office/2006/metadata/properties/metaAttributes" ct:_="" ma:_="" ma:contentTypeName="Document" ma:contentTypeID="0x01010079F111ED35F8CC479449609E8A0923A6" ma:contentTypeVersion="20" ma:contentTypeDescription="Create a new document." ma:contentTypeScope="" ma:versionID="1267097ee5f5874adfcc408041ae252e">
   <xsd:schema xmlns:xsd="http://www.w3.org/2001/XMLSchema" xmlns:xs="http://www.w3.org/2001/XMLSchema" xmlns:p="http://schemas.microsoft.com/office/2006/metadata/properties" xmlns:ns1="http://schemas.microsoft.com/sharepoint/v3" xmlns:ns2="71af3243-3dd4-4a8d-8c0d-dd76da1f02a5" xmlns:ns3="16c05727-aa75-4e4a-9b5f-8a80a1165891" xmlns:ns4="230e9df3-be65-4c73-a93b-d1236ebd677e" targetNamespace="http://schemas.microsoft.com/office/2006/metadata/properties" ma:root="true" ma:fieldsID="395891a93df65b14727750f2c06c306c" ns1:_="" ns2:_="" ns3:_="" ns4:_="">
     <xsd:import namespace="http://schemas.microsoft.com/sharepoint/v3"/>
@@ -19313,6 +19667,15 @@
 </ct:contentTypeSchema>
 </file>
 
+<file path=customXml/item2.xml><?xml version="1.0" encoding="utf-8"?>
+<?mso-contentType ?>
+<FormTemplates xmlns="http://schemas.microsoft.com/sharepoint/v3/contenttype/forms">
+  <Display>DocumentLibraryForm</Display>
+  <Edit>DocumentLibraryForm</Edit>
+  <New>DocumentLibraryForm</New>
+</FormTemplates>
+</file>
+
 <file path=customXml/item3.xml><?xml version="1.0" encoding="utf-8"?>
 <p:properties xmlns:p="http://schemas.microsoft.com/office/2006/metadata/properties" xmlns:xsi="http://www.w3.org/2001/XMLSchema-instance" xmlns:pc="http://schemas.microsoft.com/office/infopath/2007/PartnerControls">
   <documentManagement>
@@ -19333,14 +19696,6 @@
 </file>
 
 <file path=customXml/itemProps1.xml><?xml version="1.0" encoding="utf-8"?>
-<ds:datastoreItem xmlns:ds="http://schemas.openxmlformats.org/officeDocument/2006/customXml" ds:itemID="{42BC90D6-94CF-42F7-AAC4-9CF6824C54D5}">
-  <ds:schemaRefs>
-    <ds:schemaRef ds:uri="http://schemas.microsoft.com/sharepoint/v3/contenttype/forms"/>
-  </ds:schemaRefs>
-</ds:datastoreItem>
-</file>
-
-<file path=customXml/itemProps2.xml><?xml version="1.0" encoding="utf-8"?>
 <ds:datastoreItem xmlns:ds="http://schemas.openxmlformats.org/officeDocument/2006/customXml" ds:itemID="{64CF2EF3-001F-4BE9-81B3-86ECBBF9425F}">
   <ds:schemaRefs>
     <ds:schemaRef ds:uri="http://schemas.microsoft.com/office/2006/metadata/contentType"/>
@@ -19357,6 +19712,14 @@
     <ds:schemaRef ds:uri="http://purl.org/dc/elements/1.1/"/>
     <ds:schemaRef ds:uri="http://purl.org/dc/terms/"/>
     <ds:schemaRef ds:uri="http://schemas.microsoft.com/internal/obd"/>
+  </ds:schemaRefs>
+</ds:datastoreItem>
+</file>
+
+<file path=customXml/itemProps2.xml><?xml version="1.0" encoding="utf-8"?>
+<ds:datastoreItem xmlns:ds="http://schemas.openxmlformats.org/officeDocument/2006/customXml" ds:itemID="{42BC90D6-94CF-42F7-AAC4-9CF6824C54D5}">
+  <ds:schemaRefs>
+    <ds:schemaRef ds:uri="http://schemas.microsoft.com/sharepoint/v3/contenttype/forms"/>
   </ds:schemaRefs>
 </ds:datastoreItem>
 </file>

</xml_diff>